<commit_message>
Rework workshop deck to match ashleyscruse.com: Blood Red #B30022, Space Grotesk, Caveat kickers, Outfit body
</commit_message>
<xml_diff>
--- a/working/context-ai-workshop-slides.pptx
+++ b/working/context-ai-workshop-slides.pptx
@@ -3145,58 +3145,14 @@
       </p:sp>
       <p:sp>
         <p:nvSpPr>
-          <p:cNvPr id="3" name="Rectangle 2"/>
-          <p:cNvSpPr/>
-          <p:nvPr/>
-        </p:nvSpPr>
-        <p:spPr>
-          <a:xfrm>
-            <a:off x="822960" y="1417320"/>
-            <a:ext cx="1463040" cy="91440"/>
-          </a:xfrm>
-          <a:prstGeom prst="rect">
-            <a:avLst/>
-          </a:prstGeom>
-          <a:solidFill>
-            <a:srgbClr val="B50500"/>
-          </a:solidFill>
-          <a:ln>
-            <a:noFill/>
-          </a:ln>
-          <a:effectLst/>
-        </p:spPr>
-        <p:style>
-          <a:lnRef idx="1">
-            <a:schemeClr val="accent1"/>
-          </a:lnRef>
-          <a:fillRef idx="3">
-            <a:schemeClr val="accent1"/>
-          </a:fillRef>
-          <a:effectRef idx="2">
-            <a:schemeClr val="accent1"/>
-          </a:effectRef>
-          <a:fontRef idx="minor">
-            <a:schemeClr val="lt1"/>
-          </a:fontRef>
-        </p:style>
-        <p:txBody>
-          <a:bodyPr rtlCol="0" anchor="ctr"/>
-          <a:lstStyle/>
-          <a:p>
-            <a:pPr algn="ctr"/>
-          </a:p>
-        </p:txBody>
-      </p:sp>
-      <p:sp>
-        <p:nvSpPr>
-          <p:cNvPr id="4" name="TextBox 3"/>
+          <p:cNvPr id="3" name="TextBox 2"/>
           <p:cNvSpPr txBox="1"/>
           <p:nvPr/>
         </p:nvSpPr>
         <p:spPr>
           <a:xfrm>
-            <a:off x="822960" y="685800"/>
-            <a:ext cx="9144000" cy="548640"/>
+            <a:off x="822960" y="658368"/>
+            <a:ext cx="9144000" cy="640080"/>
           </a:xfrm>
           <a:prstGeom prst="rect">
             <a:avLst/>
@@ -3215,27 +3171,27 @@
               </a:lnSpc>
             </a:pPr>
             <a:r>
-              <a:rPr sz="3000" b="1">
+              <a:rPr sz="3200" b="1">
                 <a:solidFill>
                   <a:srgbClr val="9E3E58"/>
                 </a:solidFill>
                 <a:latin typeface="Caveat"/>
               </a:rPr>
-              <a:t>Grant Writing Accelerator  ·  AI Workshop</a:t>
-            </a:r>
-          </a:p>
-        </p:txBody>
-      </p:sp>
-      <p:sp>
-        <p:nvSpPr>
-          <p:cNvPr id="5" name="TextBox 4"/>
+              <a:t>grant writing accelerator, ai workshop</a:t>
+            </a:r>
+          </a:p>
+        </p:txBody>
+      </p:sp>
+      <p:sp>
+        <p:nvSpPr>
+          <p:cNvPr id="4" name="TextBox 3"/>
           <p:cNvSpPr txBox="1"/>
           <p:nvPr/>
         </p:nvSpPr>
         <p:spPr>
           <a:xfrm>
-            <a:off x="822960" y="1828800"/>
-            <a:ext cx="10515600" cy="2377440"/>
+            <a:off x="822960" y="1737360"/>
+            <a:ext cx="10881360" cy="2468880"/>
           </a:xfrm>
           <a:prstGeom prst="rect">
             <a:avLst/>
@@ -3254,27 +3210,42 @@
               </a:lnSpc>
             </a:pPr>
             <a:r>
-              <a:rPr sz="6000" b="1">
+              <a:rPr sz="6200" b="1" spc="-200">
                 <a:solidFill>
                   <a:srgbClr val="E5E6E0"/>
                 </a:solidFill>
                 <a:latin typeface="Space Grotesk"/>
               </a:rPr>
-              <a:t>IT IS NOT THE AI.
-IT IS THE CONTEXT.</a:t>
-            </a:r>
-          </a:p>
-        </p:txBody>
-      </p:sp>
-      <p:sp>
-        <p:nvSpPr>
-          <p:cNvPr id="6" name="TextBox 5"/>
+              <a:t>IT IS NOT THE AI.</a:t>
+            </a:r>
+          </a:p>
+          <a:p>
+            <a:pPr algn="l">
+              <a:lnSpc>
+                <a:spcPct val="100000"/>
+              </a:lnSpc>
+            </a:pPr>
+            <a:r>
+              <a:rPr sz="6200" b="1" spc="-200">
+                <a:solidFill>
+                  <a:srgbClr val="E5E6E0"/>
+                </a:solidFill>
+                <a:latin typeface="Space Grotesk"/>
+              </a:rPr>
+              <a:t>IT IS THE CONTEXT.</a:t>
+            </a:r>
+          </a:p>
+        </p:txBody>
+      </p:sp>
+      <p:sp>
+        <p:nvSpPr>
+          <p:cNvPr id="5" name="TextBox 4"/>
           <p:cNvSpPr txBox="1"/>
           <p:nvPr/>
         </p:nvSpPr>
         <p:spPr>
           <a:xfrm>
-            <a:off x="822960" y="4480560"/>
+            <a:off x="822960" y="4526280"/>
             <a:ext cx="10058400" cy="731520"/>
           </a:xfrm>
           <a:prstGeom prst="rect">
@@ -3294,20 +3265,20 @@
               </a:lnSpc>
             </a:pPr>
             <a:r>
-              <a:rPr sz="2600" b="0">
-                <a:solidFill>
-                  <a:srgbClr val="B9BAB4"/>
-                </a:solidFill>
-                <a:latin typeface="Outfit"/>
-              </a:rPr>
-              <a:t>A short conversation before we build.</a:t>
-            </a:r>
-          </a:p>
-        </p:txBody>
-      </p:sp>
-      <p:sp>
-        <p:nvSpPr>
-          <p:cNvPr id="7" name="TextBox 6"/>
+              <a:rPr sz="3000" b="1">
+                <a:solidFill>
+                  <a:srgbClr val="B30022"/>
+                </a:solidFill>
+                <a:latin typeface="Caveat"/>
+              </a:rPr>
+              <a:t>a short conversation before we build.</a:t>
+            </a:r>
+          </a:p>
+        </p:txBody>
+      </p:sp>
+      <p:sp>
+        <p:nvSpPr>
+          <p:cNvPr id="6" name="TextBox 5"/>
           <p:cNvSpPr txBox="1"/>
           <p:nvPr/>
         </p:nvSpPr>
@@ -3333,11 +3304,11 @@
               </a:lnSpc>
             </a:pPr>
             <a:r>
-              <a:rPr sz="1400" b="0">
+              <a:rPr sz="1200" b="1" spc="150">
                 <a:solidFill>
                   <a:srgbClr val="B9BAB4"/>
                 </a:solidFill>
-                <a:latin typeface="Outfit"/>
+                <a:latin typeface="Space Grotesk"/>
               </a:rPr>
               <a:t>ashleyscruse.com</a:t>
             </a:r>
@@ -3414,8 +3385,8 @@
         </p:nvSpPr>
         <p:spPr>
           <a:xfrm>
-            <a:off x="822960" y="685800"/>
-            <a:ext cx="9144000" cy="548640"/>
+            <a:off x="822960" y="658368"/>
+            <a:ext cx="9144000" cy="640080"/>
           </a:xfrm>
           <a:prstGeom prst="rect">
             <a:avLst/>
@@ -3434,13 +3405,13 @@
               </a:lnSpc>
             </a:pPr>
             <a:r>
-              <a:rPr sz="3000" b="1">
+              <a:rPr sz="3200" b="1">
                 <a:solidFill>
                   <a:srgbClr val="9E3E58"/>
                 </a:solidFill>
                 <a:latin typeface="Caveat"/>
               </a:rPr>
-              <a:t>Good habits</a:t>
+              <a:t>good habits</a:t>
             </a:r>
           </a:p>
         </p:txBody>
@@ -3453,8 +3424,8 @@
         </p:nvSpPr>
         <p:spPr>
           <a:xfrm>
-            <a:off x="822960" y="1280160"/>
-            <a:ext cx="10515600" cy="914400"/>
+            <a:off x="822960" y="1234440"/>
+            <a:ext cx="10607040" cy="1280160"/>
           </a:xfrm>
           <a:prstGeom prst="rect">
             <a:avLst/>
@@ -3469,11 +3440,11 @@
           <a:p>
             <a:pPr algn="l">
               <a:lnSpc>
-                <a:spcPct val="110000"/>
+                <a:spcPct val="103000"/>
               </a:lnSpc>
             </a:pPr>
             <a:r>
-              <a:rPr sz="4000" b="1">
+              <a:rPr sz="4200" b="1" spc="-150">
                 <a:solidFill>
                   <a:srgbClr val="18171F"/>
                 </a:solidFill>
@@ -3493,7 +3464,7 @@
         <p:spPr>
           <a:xfrm>
             <a:off x="822960" y="2651760"/>
-            <a:ext cx="10515600" cy="4114800"/>
+            <a:ext cx="10607040" cy="3840480"/>
           </a:xfrm>
           <a:prstGeom prst="rect">
             <a:avLst/>
@@ -3508,16 +3479,16 @@
           <a:p>
             <a:pPr>
               <a:lnSpc>
-                <a:spcPct val="115000"/>
+                <a:spcPct val="112000"/>
               </a:lnSpc>
               <a:spcAft>
-                <a:spcPts val="1400"/>
+                <a:spcPts val="1600"/>
               </a:spcAft>
             </a:pPr>
             <a:r>
-              <a:rPr sz="2600" b="1">
-                <a:solidFill>
-                  <a:srgbClr val="B50500"/>
+              <a:rPr sz="2600" b="1" spc="-50">
+                <a:solidFill>
+                  <a:srgbClr val="B30022"/>
                 </a:solidFill>
                 <a:latin typeface="Space Grotesk"/>
               </a:rPr>
@@ -3536,16 +3507,16 @@
           <a:p>
             <a:pPr>
               <a:lnSpc>
-                <a:spcPct val="115000"/>
+                <a:spcPct val="112000"/>
               </a:lnSpc>
               <a:spcAft>
-                <a:spcPts val="1400"/>
+                <a:spcPts val="1600"/>
               </a:spcAft>
             </a:pPr>
             <a:r>
-              <a:rPr sz="2600" b="1">
-                <a:solidFill>
-                  <a:srgbClr val="B50500"/>
+              <a:rPr sz="2600" b="1" spc="-50">
+                <a:solidFill>
+                  <a:srgbClr val="B30022"/>
                 </a:solidFill>
                 <a:latin typeface="Space Grotesk"/>
               </a:rPr>
@@ -3564,16 +3535,16 @@
           <a:p>
             <a:pPr>
               <a:lnSpc>
-                <a:spcPct val="115000"/>
+                <a:spcPct val="112000"/>
               </a:lnSpc>
               <a:spcAft>
-                <a:spcPts val="1400"/>
+                <a:spcPts val="1600"/>
               </a:spcAft>
             </a:pPr>
             <a:r>
-              <a:rPr sz="2600" b="1">
-                <a:solidFill>
-                  <a:srgbClr val="B50500"/>
+              <a:rPr sz="2600" b="1" spc="-50">
+                <a:solidFill>
+                  <a:srgbClr val="B30022"/>
                 </a:solidFill>
                 <a:latin typeface="Space Grotesk"/>
               </a:rPr>
@@ -3662,13 +3633,13 @@
         <p:spPr>
           <a:xfrm>
             <a:off x="822960" y="1371600"/>
-            <a:ext cx="1463040" cy="91440"/>
+            <a:ext cx="1371600" cy="82296"/>
           </a:xfrm>
           <a:prstGeom prst="rect">
             <a:avLst/>
           </a:prstGeom>
           <a:solidFill>
-            <a:srgbClr val="B50500"/>
+            <a:srgbClr val="B30022"/>
           </a:solidFill>
           <a:ln>
             <a:noFill/>
@@ -3706,7 +3677,7 @@
         <p:spPr>
           <a:xfrm>
             <a:off x="822960" y="1600200"/>
-            <a:ext cx="10515600" cy="1097280"/>
+            <a:ext cx="10607040" cy="1280160"/>
           </a:xfrm>
           <a:prstGeom prst="rect">
             <a:avLst/>
@@ -3721,11 +3692,11 @@
           <a:p>
             <a:pPr algn="l">
               <a:lnSpc>
-                <a:spcPct val="110000"/>
+                <a:spcPct val="103000"/>
               </a:lnSpc>
             </a:pPr>
             <a:r>
-              <a:rPr sz="4000" b="1">
+              <a:rPr sz="4000" b="1" spc="-150">
                 <a:solidFill>
                   <a:srgbClr val="E5E6E0"/>
                 </a:solidFill>
@@ -3744,8 +3715,8 @@
         </p:nvSpPr>
         <p:spPr>
           <a:xfrm>
-            <a:off x="822960" y="3108960"/>
-            <a:ext cx="10241280" cy="1828800"/>
+            <a:off x="822960" y="3063240"/>
+            <a:ext cx="10424160" cy="1828800"/>
           </a:xfrm>
           <a:prstGeom prst="rect">
             <a:avLst/>
@@ -3760,7 +3731,7 @@
           <a:p>
             <a:pPr algn="l">
               <a:lnSpc>
-                <a:spcPct val="125000"/>
+                <a:spcPct val="130000"/>
               </a:lnSpc>
             </a:pPr>
             <a:r>
@@ -3839,58 +3810,14 @@
       </p:sp>
       <p:sp>
         <p:nvSpPr>
-          <p:cNvPr id="3" name="Rectangle 2"/>
-          <p:cNvSpPr/>
-          <p:nvPr/>
-        </p:nvSpPr>
-        <p:spPr>
-          <a:xfrm>
-            <a:off x="822960" y="1463040"/>
-            <a:ext cx="1463040" cy="91440"/>
-          </a:xfrm>
-          <a:prstGeom prst="rect">
-            <a:avLst/>
-          </a:prstGeom>
-          <a:solidFill>
-            <a:srgbClr val="B50500"/>
-          </a:solidFill>
-          <a:ln>
-            <a:noFill/>
-          </a:ln>
-          <a:effectLst/>
-        </p:spPr>
-        <p:style>
-          <a:lnRef idx="1">
-            <a:schemeClr val="accent1"/>
-          </a:lnRef>
-          <a:fillRef idx="3">
-            <a:schemeClr val="accent1"/>
-          </a:fillRef>
-          <a:effectRef idx="2">
-            <a:schemeClr val="accent1"/>
-          </a:effectRef>
-          <a:fontRef idx="minor">
-            <a:schemeClr val="lt1"/>
-          </a:fontRef>
-        </p:style>
-        <p:txBody>
-          <a:bodyPr rtlCol="0" anchor="ctr"/>
-          <a:lstStyle/>
-          <a:p>
-            <a:pPr algn="ctr"/>
-          </a:p>
-        </p:txBody>
-      </p:sp>
-      <p:sp>
-        <p:nvSpPr>
-          <p:cNvPr id="4" name="TextBox 3"/>
+          <p:cNvPr id="3" name="TextBox 2"/>
           <p:cNvSpPr txBox="1"/>
           <p:nvPr/>
         </p:nvSpPr>
         <p:spPr>
           <a:xfrm>
-            <a:off x="822960" y="685800"/>
-            <a:ext cx="9144000" cy="548640"/>
+            <a:off x="822960" y="658368"/>
+            <a:ext cx="9144000" cy="640080"/>
           </a:xfrm>
           <a:prstGeom prst="rect">
             <a:avLst/>
@@ -3909,27 +3836,27 @@
               </a:lnSpc>
             </a:pPr>
             <a:r>
-              <a:rPr sz="3000" b="1">
-                <a:solidFill>
-                  <a:srgbClr val="9E3E58"/>
+              <a:rPr sz="3200" b="1">
+                <a:solidFill>
+                  <a:srgbClr val="B30022"/>
                 </a:solidFill>
                 <a:latin typeface="Caveat"/>
               </a:rPr>
-              <a:t>Let's build.</a:t>
-            </a:r>
-          </a:p>
-        </p:txBody>
-      </p:sp>
-      <p:sp>
-        <p:nvSpPr>
-          <p:cNvPr id="5" name="TextBox 4"/>
+              <a:t>let's build.</a:t>
+            </a:r>
+          </a:p>
+        </p:txBody>
+      </p:sp>
+      <p:sp>
+        <p:nvSpPr>
+          <p:cNvPr id="4" name="TextBox 3"/>
           <p:cNvSpPr txBox="1"/>
           <p:nvPr/>
         </p:nvSpPr>
         <p:spPr>
           <a:xfrm>
-            <a:off x="822960" y="2011680"/>
-            <a:ext cx="10515600" cy="2377440"/>
+            <a:off x="822960" y="1920240"/>
+            <a:ext cx="10881360" cy="2468880"/>
           </a:xfrm>
           <a:prstGeom prst="rect">
             <a:avLst/>
@@ -3948,21 +3875,36 @@
               </a:lnSpc>
             </a:pPr>
             <a:r>
-              <a:rPr sz="4800" b="1">
+              <a:rPr sz="5000" b="1" spc="-200">
                 <a:solidFill>
                   <a:srgbClr val="E5E6E0"/>
                 </a:solidFill>
                 <a:latin typeface="Space Grotesk"/>
               </a:rPr>
-              <a:t>Fill in your context once.
-Reuse it on every proposal.</a:t>
-            </a:r>
-          </a:p>
-        </p:txBody>
-      </p:sp>
-      <p:sp>
-        <p:nvSpPr>
-          <p:cNvPr id="6" name="TextBox 5"/>
+              <a:t>Fill in your context once.</a:t>
+            </a:r>
+          </a:p>
+          <a:p>
+            <a:pPr algn="l">
+              <a:lnSpc>
+                <a:spcPct val="105000"/>
+              </a:lnSpc>
+            </a:pPr>
+            <a:r>
+              <a:rPr sz="5000" b="1" spc="-200">
+                <a:solidFill>
+                  <a:srgbClr val="E5E6E0"/>
+                </a:solidFill>
+                <a:latin typeface="Space Grotesk"/>
+              </a:rPr>
+              <a:t>Reuse it on every proposal.</a:t>
+            </a:r>
+          </a:p>
+        </p:txBody>
+      </p:sp>
+      <p:sp>
+        <p:nvSpPr>
+          <p:cNvPr id="5" name="TextBox 4"/>
           <p:cNvSpPr txBox="1"/>
           <p:nvPr/>
         </p:nvSpPr>
@@ -3988,11 +3930,11 @@
               </a:lnSpc>
             </a:pPr>
             <a:r>
-              <a:rPr sz="1400" b="0">
+              <a:rPr sz="1200" b="1" spc="150">
                 <a:solidFill>
                   <a:srgbClr val="B9BAB4"/>
                 </a:solidFill>
-                <a:latin typeface="Outfit"/>
+                <a:latin typeface="Space Grotesk"/>
               </a:rPr>
               <a:t>ashleyscruse.com</a:t>
             </a:r>
@@ -4069,8 +4011,8 @@
         </p:nvSpPr>
         <p:spPr>
           <a:xfrm>
-            <a:off x="822960" y="685800"/>
-            <a:ext cx="9144000" cy="548640"/>
+            <a:off x="822960" y="658368"/>
+            <a:ext cx="9144000" cy="640080"/>
           </a:xfrm>
           <a:prstGeom prst="rect">
             <a:avLst/>
@@ -4089,13 +4031,13 @@
               </a:lnSpc>
             </a:pPr>
             <a:r>
-              <a:rPr sz="3000" b="1">
+              <a:rPr sz="3200" b="1">
                 <a:solidFill>
                   <a:srgbClr val="9E3E58"/>
                 </a:solidFill>
                 <a:latin typeface="Caveat"/>
               </a:rPr>
-              <a:t>The problem</a:t>
+              <a:t>the problem</a:t>
             </a:r>
           </a:p>
         </p:txBody>
@@ -4108,8 +4050,8 @@
         </p:nvSpPr>
         <p:spPr>
           <a:xfrm>
-            <a:off x="822960" y="1280160"/>
-            <a:ext cx="10515600" cy="914400"/>
+            <a:off x="822960" y="1234440"/>
+            <a:ext cx="10607040" cy="1280160"/>
           </a:xfrm>
           <a:prstGeom prst="rect">
             <a:avLst/>
@@ -4124,11 +4066,11 @@
           <a:p>
             <a:pPr algn="l">
               <a:lnSpc>
-                <a:spcPct val="110000"/>
+                <a:spcPct val="103000"/>
               </a:lnSpc>
             </a:pPr>
             <a:r>
-              <a:rPr sz="4000" b="1">
+              <a:rPr sz="4200" b="1" spc="-150">
                 <a:solidFill>
                   <a:srgbClr val="18171F"/>
                 </a:solidFill>
@@ -4148,7 +4090,7 @@
         <p:spPr>
           <a:xfrm>
             <a:off x="822960" y="2651760"/>
-            <a:ext cx="10241280" cy="2743200"/>
+            <a:ext cx="10424160" cy="2743200"/>
           </a:xfrm>
           <a:prstGeom prst="rect">
             <a:avLst/>
@@ -4163,7 +4105,7 @@
           <a:p>
             <a:pPr algn="l">
               <a:lnSpc>
-                <a:spcPct val="125000"/>
+                <a:spcPct val="130000"/>
               </a:lnSpc>
             </a:pPr>
             <a:r>
@@ -4248,8 +4190,8 @@
         </p:nvSpPr>
         <p:spPr>
           <a:xfrm>
-            <a:off x="822960" y="685800"/>
-            <a:ext cx="9144000" cy="548640"/>
+            <a:off x="822960" y="658368"/>
+            <a:ext cx="9144000" cy="640080"/>
           </a:xfrm>
           <a:prstGeom prst="rect">
             <a:avLst/>
@@ -4268,13 +4210,13 @@
               </a:lnSpc>
             </a:pPr>
             <a:r>
-              <a:rPr sz="3000" b="1">
+              <a:rPr sz="3200" b="1">
                 <a:solidFill>
                   <a:srgbClr val="9E3E58"/>
                 </a:solidFill>
                 <a:latin typeface="Caveat"/>
               </a:rPr>
-              <a:t>The fix</a:t>
+              <a:t>the fix</a:t>
             </a:r>
           </a:p>
         </p:txBody>
@@ -4287,8 +4229,8 @@
         </p:nvSpPr>
         <p:spPr>
           <a:xfrm>
-            <a:off x="822960" y="1280160"/>
-            <a:ext cx="10515600" cy="914400"/>
+            <a:off x="822960" y="1234440"/>
+            <a:ext cx="10607040" cy="1280160"/>
           </a:xfrm>
           <a:prstGeom prst="rect">
             <a:avLst/>
@@ -4303,11 +4245,11 @@
           <a:p>
             <a:pPr algn="l">
               <a:lnSpc>
-                <a:spcPct val="110000"/>
+                <a:spcPct val="103000"/>
               </a:lnSpc>
             </a:pPr>
             <a:r>
-              <a:rPr sz="4000" b="1">
+              <a:rPr sz="4200" b="1" spc="-150">
                 <a:solidFill>
                   <a:srgbClr val="18171F"/>
                 </a:solidFill>
@@ -4327,7 +4269,7 @@
         <p:spPr>
           <a:xfrm>
             <a:off x="822960" y="2651760"/>
-            <a:ext cx="10241280" cy="2743200"/>
+            <a:ext cx="10424160" cy="2743200"/>
           </a:xfrm>
           <a:prstGeom prst="rect">
             <a:avLst/>
@@ -4342,7 +4284,7 @@
           <a:p>
             <a:pPr algn="l">
               <a:lnSpc>
-                <a:spcPct val="125000"/>
+                <a:spcPct val="130000"/>
               </a:lnSpc>
             </a:pPr>
             <a:r>
@@ -4428,13 +4370,13 @@
         <p:spPr>
           <a:xfrm>
             <a:off x="822960" y="1371600"/>
-            <a:ext cx="1463040" cy="91440"/>
+            <a:ext cx="1371600" cy="82296"/>
           </a:xfrm>
           <a:prstGeom prst="rect">
             <a:avLst/>
           </a:prstGeom>
           <a:solidFill>
-            <a:srgbClr val="B50500"/>
+            <a:srgbClr val="B30022"/>
           </a:solidFill>
           <a:ln>
             <a:noFill/>
@@ -4472,7 +4414,7 @@
         <p:spPr>
           <a:xfrm>
             <a:off x="822960" y="1600200"/>
-            <a:ext cx="10515600" cy="914400"/>
+            <a:ext cx="10607040" cy="1280160"/>
           </a:xfrm>
           <a:prstGeom prst="rect">
             <a:avLst/>
@@ -4487,11 +4429,11 @@
           <a:p>
             <a:pPr algn="l">
               <a:lnSpc>
-                <a:spcPct val="110000"/>
+                <a:spcPct val="103000"/>
               </a:lnSpc>
             </a:pPr>
             <a:r>
-              <a:rPr sz="4200" b="1">
+              <a:rPr sz="4400" b="1" spc="-150">
                 <a:solidFill>
                   <a:srgbClr val="E5E6E0"/>
                 </a:solidFill>
@@ -4511,7 +4453,7 @@
         <p:spPr>
           <a:xfrm>
             <a:off x="822960" y="2834640"/>
-            <a:ext cx="10515600" cy="4114800"/>
+            <a:ext cx="10607040" cy="3840480"/>
           </a:xfrm>
           <a:prstGeom prst="rect">
             <a:avLst/>
@@ -4526,16 +4468,16 @@
           <a:p>
             <a:pPr>
               <a:lnSpc>
-                <a:spcPct val="115000"/>
+                <a:spcPct val="112000"/>
               </a:lnSpc>
               <a:spcAft>
-                <a:spcPts val="1400"/>
+                <a:spcPts val="1600"/>
               </a:spcAft>
             </a:pPr>
             <a:r>
-              <a:rPr sz="2700" b="1">
-                <a:solidFill>
-                  <a:srgbClr val="B50500"/>
+              <a:rPr sz="2700" b="1" spc="-50">
+                <a:solidFill>
+                  <a:srgbClr val="B30022"/>
                 </a:solidFill>
                 <a:latin typeface="Space Grotesk"/>
               </a:rPr>
@@ -4554,16 +4496,16 @@
           <a:p>
             <a:pPr>
               <a:lnSpc>
-                <a:spcPct val="115000"/>
+                <a:spcPct val="112000"/>
               </a:lnSpc>
               <a:spcAft>
-                <a:spcPts val="1400"/>
+                <a:spcPts val="1600"/>
               </a:spcAft>
             </a:pPr>
             <a:r>
-              <a:rPr sz="2700" b="1">
-                <a:solidFill>
-                  <a:srgbClr val="B50500"/>
+              <a:rPr sz="2700" b="1" spc="-50">
+                <a:solidFill>
+                  <a:srgbClr val="B30022"/>
                 </a:solidFill>
                 <a:latin typeface="Space Grotesk"/>
               </a:rPr>
@@ -4582,16 +4524,16 @@
           <a:p>
             <a:pPr>
               <a:lnSpc>
-                <a:spcPct val="115000"/>
+                <a:spcPct val="112000"/>
               </a:lnSpc>
               <a:spcAft>
-                <a:spcPts val="1400"/>
+                <a:spcPts val="1600"/>
               </a:spcAft>
             </a:pPr>
             <a:r>
-              <a:rPr sz="2700" b="1">
-                <a:solidFill>
-                  <a:srgbClr val="B50500"/>
+              <a:rPr sz="2700" b="1" spc="-50">
+                <a:solidFill>
+                  <a:srgbClr val="B30022"/>
                 </a:solidFill>
                 <a:latin typeface="Space Grotesk"/>
               </a:rPr>
@@ -4679,8 +4621,8 @@
         </p:nvSpPr>
         <p:spPr>
           <a:xfrm>
-            <a:off x="822960" y="685800"/>
-            <a:ext cx="9144000" cy="548640"/>
+            <a:off x="822960" y="658368"/>
+            <a:ext cx="9144000" cy="640080"/>
           </a:xfrm>
           <a:prstGeom prst="rect">
             <a:avLst/>
@@ -4699,13 +4641,13 @@
               </a:lnSpc>
             </a:pPr>
             <a:r>
-              <a:rPr sz="3000" b="1">
+              <a:rPr sz="3200" b="1">
                 <a:solidFill>
                   <a:srgbClr val="9E3E58"/>
                 </a:solidFill>
                 <a:latin typeface="Caveat"/>
               </a:rPr>
-              <a:t>Same page</a:t>
+              <a:t>same page</a:t>
             </a:r>
           </a:p>
         </p:txBody>
@@ -4718,8 +4660,8 @@
         </p:nvSpPr>
         <p:spPr>
           <a:xfrm>
-            <a:off x="822960" y="1280160"/>
-            <a:ext cx="10515600" cy="914400"/>
+            <a:off x="822960" y="1234440"/>
+            <a:ext cx="10607040" cy="1280160"/>
           </a:xfrm>
           <a:prstGeom prst="rect">
             <a:avLst/>
@@ -4734,11 +4676,11 @@
           <a:p>
             <a:pPr algn="l">
               <a:lnSpc>
-                <a:spcPct val="110000"/>
+                <a:spcPct val="103000"/>
               </a:lnSpc>
             </a:pPr>
             <a:r>
-              <a:rPr sz="4000" b="1">
+              <a:rPr sz="4000" b="1" spc="-150">
                 <a:solidFill>
                   <a:srgbClr val="18171F"/>
                 </a:solidFill>
@@ -4758,7 +4700,7 @@
         <p:spPr>
           <a:xfrm>
             <a:off x="822960" y="2651760"/>
-            <a:ext cx="10515600" cy="4114800"/>
+            <a:ext cx="10607040" cy="3840480"/>
           </a:xfrm>
           <a:prstGeom prst="rect">
             <a:avLst/>
@@ -4773,16 +4715,16 @@
           <a:p>
             <a:pPr>
               <a:lnSpc>
-                <a:spcPct val="115000"/>
+                <a:spcPct val="112000"/>
               </a:lnSpc>
               <a:spcAft>
-                <a:spcPts val="1400"/>
+                <a:spcPts val="1600"/>
               </a:spcAft>
             </a:pPr>
             <a:r>
-              <a:rPr sz="2500" b="1">
-                <a:solidFill>
-                  <a:srgbClr val="B50500"/>
+              <a:rPr sz="2500" b="1" spc="-50">
+                <a:solidFill>
+                  <a:srgbClr val="B30022"/>
                 </a:solidFill>
                 <a:latin typeface="Space Grotesk"/>
               </a:rPr>
@@ -4801,16 +4743,16 @@
           <a:p>
             <a:pPr>
               <a:lnSpc>
-                <a:spcPct val="115000"/>
+                <a:spcPct val="112000"/>
               </a:lnSpc>
               <a:spcAft>
-                <a:spcPts val="1400"/>
+                <a:spcPts val="1600"/>
               </a:spcAft>
             </a:pPr>
             <a:r>
-              <a:rPr sz="2500" b="1">
-                <a:solidFill>
-                  <a:srgbClr val="B50500"/>
+              <a:rPr sz="2500" b="1" spc="-50">
+                <a:solidFill>
+                  <a:srgbClr val="B30022"/>
                 </a:solidFill>
                 <a:latin typeface="Space Grotesk"/>
               </a:rPr>
@@ -4829,16 +4771,16 @@
           <a:p>
             <a:pPr>
               <a:lnSpc>
-                <a:spcPct val="115000"/>
+                <a:spcPct val="112000"/>
               </a:lnSpc>
               <a:spcAft>
-                <a:spcPts val="1400"/>
+                <a:spcPts val="1600"/>
               </a:spcAft>
             </a:pPr>
             <a:r>
-              <a:rPr sz="2500" b="1">
-                <a:solidFill>
-                  <a:srgbClr val="B50500"/>
+              <a:rPr sz="2500" b="1" spc="-50">
+                <a:solidFill>
+                  <a:srgbClr val="B30022"/>
                 </a:solidFill>
                 <a:latin typeface="Space Grotesk"/>
               </a:rPr>
@@ -4926,8 +4868,8 @@
         </p:nvSpPr>
         <p:spPr>
           <a:xfrm>
-            <a:off x="822960" y="685800"/>
-            <a:ext cx="9144000" cy="548640"/>
+            <a:off x="822960" y="658368"/>
+            <a:ext cx="9144000" cy="640080"/>
           </a:xfrm>
           <a:prstGeom prst="rect">
             <a:avLst/>
@@ -4946,13 +4888,13 @@
               </a:lnSpc>
             </a:pPr>
             <a:r>
-              <a:rPr sz="3000" b="1">
+              <a:rPr sz="3200" b="1">
                 <a:solidFill>
                   <a:srgbClr val="9E3E58"/>
                 </a:solidFill>
                 <a:latin typeface="Caveat"/>
               </a:rPr>
-              <a:t>Same page</a:t>
+              <a:t>same page</a:t>
             </a:r>
           </a:p>
         </p:txBody>
@@ -4965,8 +4907,8 @@
         </p:nvSpPr>
         <p:spPr>
           <a:xfrm>
-            <a:off x="822960" y="1280160"/>
-            <a:ext cx="10515600" cy="914400"/>
+            <a:off x="822960" y="1234440"/>
+            <a:ext cx="10607040" cy="1280160"/>
           </a:xfrm>
           <a:prstGeom prst="rect">
             <a:avLst/>
@@ -4981,11 +4923,11 @@
           <a:p>
             <a:pPr algn="l">
               <a:lnSpc>
-                <a:spcPct val="110000"/>
+                <a:spcPct val="103000"/>
               </a:lnSpc>
             </a:pPr>
             <a:r>
-              <a:rPr sz="3800" b="1">
+              <a:rPr sz="3800" b="1" spc="-150">
                 <a:solidFill>
                   <a:srgbClr val="18171F"/>
                 </a:solidFill>
@@ -5005,7 +4947,7 @@
         <p:spPr>
           <a:xfrm>
             <a:off x="822960" y="2651760"/>
-            <a:ext cx="10515600" cy="4114800"/>
+            <a:ext cx="10607040" cy="3840480"/>
           </a:xfrm>
           <a:prstGeom prst="rect">
             <a:avLst/>
@@ -5020,16 +4962,16 @@
           <a:p>
             <a:pPr>
               <a:lnSpc>
-                <a:spcPct val="115000"/>
+                <a:spcPct val="112000"/>
               </a:lnSpc>
               <a:spcAft>
-                <a:spcPts val="1400"/>
+                <a:spcPts val="1600"/>
               </a:spcAft>
             </a:pPr>
             <a:r>
-              <a:rPr sz="2500" b="1">
-                <a:solidFill>
-                  <a:srgbClr val="B50500"/>
+              <a:rPr sz="2500" b="1" spc="-50">
+                <a:solidFill>
+                  <a:srgbClr val="B30022"/>
                 </a:solidFill>
                 <a:latin typeface="Space Grotesk"/>
               </a:rPr>
@@ -5048,16 +4990,16 @@
           <a:p>
             <a:pPr>
               <a:lnSpc>
-                <a:spcPct val="115000"/>
+                <a:spcPct val="112000"/>
               </a:lnSpc>
               <a:spcAft>
-                <a:spcPts val="1400"/>
+                <a:spcPts val="1600"/>
               </a:spcAft>
             </a:pPr>
             <a:r>
-              <a:rPr sz="2500" b="1">
-                <a:solidFill>
-                  <a:srgbClr val="B50500"/>
+              <a:rPr sz="2500" b="1" spc="-50">
+                <a:solidFill>
+                  <a:srgbClr val="B30022"/>
                 </a:solidFill>
                 <a:latin typeface="Space Grotesk"/>
               </a:rPr>
@@ -5076,16 +5018,16 @@
           <a:p>
             <a:pPr>
               <a:lnSpc>
-                <a:spcPct val="115000"/>
+                <a:spcPct val="112000"/>
               </a:lnSpc>
               <a:spcAft>
-                <a:spcPts val="1400"/>
+                <a:spcPts val="1600"/>
               </a:spcAft>
             </a:pPr>
             <a:r>
-              <a:rPr sz="2500" b="1">
-                <a:solidFill>
-                  <a:srgbClr val="B50500"/>
+              <a:rPr sz="2500" b="1" spc="-50">
+                <a:solidFill>
+                  <a:srgbClr val="B30022"/>
                 </a:solidFill>
                 <a:latin typeface="Space Grotesk"/>
               </a:rPr>
@@ -5173,8 +5115,8 @@
         </p:nvSpPr>
         <p:spPr>
           <a:xfrm>
-            <a:off x="822960" y="685800"/>
-            <a:ext cx="9144000" cy="548640"/>
+            <a:off x="822960" y="658368"/>
+            <a:ext cx="9144000" cy="640080"/>
           </a:xfrm>
           <a:prstGeom prst="rect">
             <a:avLst/>
@@ -5193,13 +5135,13 @@
               </a:lnSpc>
             </a:pPr>
             <a:r>
-              <a:rPr sz="3000" b="1">
+              <a:rPr sz="3200" b="1">
                 <a:solidFill>
                   <a:srgbClr val="9E3E58"/>
                 </a:solidFill>
                 <a:latin typeface="Caveat"/>
               </a:rPr>
-              <a:t>Same page</a:t>
+              <a:t>same page</a:t>
             </a:r>
           </a:p>
         </p:txBody>
@@ -5212,8 +5154,8 @@
         </p:nvSpPr>
         <p:spPr>
           <a:xfrm>
-            <a:off x="822960" y="1280160"/>
-            <a:ext cx="10515600" cy="914400"/>
+            <a:off x="822960" y="1234440"/>
+            <a:ext cx="10607040" cy="1280160"/>
           </a:xfrm>
           <a:prstGeom prst="rect">
             <a:avLst/>
@@ -5228,11 +5170,11 @@
           <a:p>
             <a:pPr algn="l">
               <a:lnSpc>
-                <a:spcPct val="110000"/>
+                <a:spcPct val="103000"/>
               </a:lnSpc>
             </a:pPr>
             <a:r>
-              <a:rPr sz="3600" b="1">
+              <a:rPr sz="3600" b="1" spc="-150">
                 <a:solidFill>
                   <a:srgbClr val="18171F"/>
                 </a:solidFill>
@@ -5252,7 +5194,7 @@
         <p:spPr>
           <a:xfrm>
             <a:off x="822960" y="2651760"/>
-            <a:ext cx="10515600" cy="4114800"/>
+            <a:ext cx="10607040" cy="3840480"/>
           </a:xfrm>
           <a:prstGeom prst="rect">
             <a:avLst/>
@@ -5267,16 +5209,16 @@
           <a:p>
             <a:pPr>
               <a:lnSpc>
-                <a:spcPct val="115000"/>
+                <a:spcPct val="112000"/>
               </a:lnSpc>
               <a:spcAft>
-                <a:spcPts val="1400"/>
+                <a:spcPts val="1600"/>
               </a:spcAft>
             </a:pPr>
             <a:r>
-              <a:rPr sz="2500" b="1">
-                <a:solidFill>
-                  <a:srgbClr val="B50500"/>
+              <a:rPr sz="2500" b="1" spc="-50">
+                <a:solidFill>
+                  <a:srgbClr val="B30022"/>
                 </a:solidFill>
                 <a:latin typeface="Space Grotesk"/>
               </a:rPr>
@@ -5295,16 +5237,16 @@
           <a:p>
             <a:pPr>
               <a:lnSpc>
-                <a:spcPct val="115000"/>
+                <a:spcPct val="112000"/>
               </a:lnSpc>
               <a:spcAft>
-                <a:spcPts val="1400"/>
+                <a:spcPts val="1600"/>
               </a:spcAft>
             </a:pPr>
             <a:r>
-              <a:rPr sz="2500" b="1">
-                <a:solidFill>
-                  <a:srgbClr val="B50500"/>
+              <a:rPr sz="2500" b="1" spc="-50">
+                <a:solidFill>
+                  <a:srgbClr val="B30022"/>
                 </a:solidFill>
                 <a:latin typeface="Space Grotesk"/>
               </a:rPr>
@@ -5323,16 +5265,16 @@
           <a:p>
             <a:pPr>
               <a:lnSpc>
-                <a:spcPct val="115000"/>
+                <a:spcPct val="112000"/>
               </a:lnSpc>
               <a:spcAft>
-                <a:spcPts val="1400"/>
+                <a:spcPts val="1600"/>
               </a:spcAft>
             </a:pPr>
             <a:r>
-              <a:rPr sz="2500" b="1">
-                <a:solidFill>
-                  <a:srgbClr val="B50500"/>
+              <a:rPr sz="2500" b="1" spc="-50">
+                <a:solidFill>
+                  <a:srgbClr val="B30022"/>
                 </a:solidFill>
                 <a:latin typeface="Space Grotesk"/>
               </a:rPr>
@@ -5420,8 +5362,8 @@
         </p:nvSpPr>
         <p:spPr>
           <a:xfrm>
-            <a:off x="822960" y="685800"/>
-            <a:ext cx="9144000" cy="548640"/>
+            <a:off x="822960" y="658368"/>
+            <a:ext cx="9144000" cy="640080"/>
           </a:xfrm>
           <a:prstGeom prst="rect">
             <a:avLst/>
@@ -5440,13 +5382,13 @@
               </a:lnSpc>
             </a:pPr>
             <a:r>
-              <a:rPr sz="3000" b="1">
+              <a:rPr sz="3200" b="1">
                 <a:solidFill>
                   <a:srgbClr val="9E3E58"/>
                 </a:solidFill>
                 <a:latin typeface="Caveat"/>
               </a:rPr>
-              <a:t>Good habits</a:t>
+              <a:t>good habits</a:t>
             </a:r>
           </a:p>
         </p:txBody>
@@ -5459,8 +5401,8 @@
         </p:nvSpPr>
         <p:spPr>
           <a:xfrm>
-            <a:off x="822960" y="1280160"/>
-            <a:ext cx="10515600" cy="914400"/>
+            <a:off x="822960" y="1234440"/>
+            <a:ext cx="10607040" cy="1280160"/>
           </a:xfrm>
           <a:prstGeom prst="rect">
             <a:avLst/>
@@ -5475,11 +5417,11 @@
           <a:p>
             <a:pPr algn="l">
               <a:lnSpc>
-                <a:spcPct val="110000"/>
+                <a:spcPct val="103000"/>
               </a:lnSpc>
             </a:pPr>
             <a:r>
-              <a:rPr sz="4000" b="1">
+              <a:rPr sz="4200" b="1" spc="-150">
                 <a:solidFill>
                   <a:srgbClr val="18171F"/>
                 </a:solidFill>
@@ -5499,7 +5441,7 @@
         <p:spPr>
           <a:xfrm>
             <a:off x="822960" y="2651760"/>
-            <a:ext cx="10515600" cy="4114800"/>
+            <a:ext cx="10607040" cy="3840480"/>
           </a:xfrm>
           <a:prstGeom prst="rect">
             <a:avLst/>
@@ -5514,16 +5456,16 @@
           <a:p>
             <a:pPr>
               <a:lnSpc>
-                <a:spcPct val="115000"/>
+                <a:spcPct val="112000"/>
               </a:lnSpc>
               <a:spcAft>
-                <a:spcPts val="1400"/>
+                <a:spcPts val="1600"/>
               </a:spcAft>
             </a:pPr>
             <a:r>
-              <a:rPr sz="2600" b="1">
-                <a:solidFill>
-                  <a:srgbClr val="B50500"/>
+              <a:rPr sz="2600" b="1" spc="-50">
+                <a:solidFill>
+                  <a:srgbClr val="B30022"/>
                 </a:solidFill>
                 <a:latin typeface="Space Grotesk"/>
               </a:rPr>
@@ -5542,16 +5484,16 @@
           <a:p>
             <a:pPr>
               <a:lnSpc>
-                <a:spcPct val="115000"/>
+                <a:spcPct val="112000"/>
               </a:lnSpc>
               <a:spcAft>
-                <a:spcPts val="1400"/>
+                <a:spcPts val="1600"/>
               </a:spcAft>
             </a:pPr>
             <a:r>
-              <a:rPr sz="2600" b="1">
-                <a:solidFill>
-                  <a:srgbClr val="B50500"/>
+              <a:rPr sz="2600" b="1" spc="-50">
+                <a:solidFill>
+                  <a:srgbClr val="B30022"/>
                 </a:solidFill>
                 <a:latin typeface="Space Grotesk"/>
               </a:rPr>
@@ -5570,16 +5512,16 @@
           <a:p>
             <a:pPr>
               <a:lnSpc>
-                <a:spcPct val="115000"/>
+                <a:spcPct val="112000"/>
               </a:lnSpc>
               <a:spcAft>
-                <a:spcPts val="1400"/>
+                <a:spcPts val="1600"/>
               </a:spcAft>
             </a:pPr>
             <a:r>
-              <a:rPr sz="2600" b="1">
-                <a:solidFill>
-                  <a:srgbClr val="B50500"/>
+              <a:rPr sz="2600" b="1" spc="-50">
+                <a:solidFill>
+                  <a:srgbClr val="B30022"/>
                 </a:solidFill>
                 <a:latin typeface="Space Grotesk"/>
               </a:rPr>
@@ -5667,8 +5609,8 @@
         </p:nvSpPr>
         <p:spPr>
           <a:xfrm>
-            <a:off x="822960" y="685800"/>
-            <a:ext cx="9144000" cy="548640"/>
+            <a:off x="822960" y="658368"/>
+            <a:ext cx="9144000" cy="640080"/>
           </a:xfrm>
           <a:prstGeom prst="rect">
             <a:avLst/>
@@ -5687,13 +5629,13 @@
               </a:lnSpc>
             </a:pPr>
             <a:r>
-              <a:rPr sz="3000" b="1">
+              <a:rPr sz="3200" b="1">
                 <a:solidFill>
                   <a:srgbClr val="9E3E58"/>
                 </a:solidFill>
                 <a:latin typeface="Caveat"/>
               </a:rPr>
-              <a:t>Good habits</a:t>
+              <a:t>good habits</a:t>
             </a:r>
           </a:p>
         </p:txBody>
@@ -5706,8 +5648,8 @@
         </p:nvSpPr>
         <p:spPr>
           <a:xfrm>
-            <a:off x="822960" y="1280160"/>
-            <a:ext cx="10515600" cy="914400"/>
+            <a:off x="822960" y="1234440"/>
+            <a:ext cx="10607040" cy="1280160"/>
           </a:xfrm>
           <a:prstGeom prst="rect">
             <a:avLst/>
@@ -5722,11 +5664,11 @@
           <a:p>
             <a:pPr algn="l">
               <a:lnSpc>
-                <a:spcPct val="110000"/>
+                <a:spcPct val="103000"/>
               </a:lnSpc>
             </a:pPr>
             <a:r>
-              <a:rPr sz="4000" b="1">
+              <a:rPr sz="4200" b="1" spc="-150">
                 <a:solidFill>
                   <a:srgbClr val="18171F"/>
                 </a:solidFill>
@@ -5746,7 +5688,7 @@
         <p:spPr>
           <a:xfrm>
             <a:off x="822960" y="2651760"/>
-            <a:ext cx="10515600" cy="4114800"/>
+            <a:ext cx="10607040" cy="3840480"/>
           </a:xfrm>
           <a:prstGeom prst="rect">
             <a:avLst/>
@@ -5761,16 +5703,16 @@
           <a:p>
             <a:pPr>
               <a:lnSpc>
-                <a:spcPct val="115000"/>
+                <a:spcPct val="112000"/>
               </a:lnSpc>
               <a:spcAft>
-                <a:spcPts val="1400"/>
+                <a:spcPts val="1600"/>
               </a:spcAft>
             </a:pPr>
             <a:r>
-              <a:rPr sz="2600" b="1">
-                <a:solidFill>
-                  <a:srgbClr val="B50500"/>
+              <a:rPr sz="2600" b="1" spc="-50">
+                <a:solidFill>
+                  <a:srgbClr val="B30022"/>
                 </a:solidFill>
                 <a:latin typeface="Space Grotesk"/>
               </a:rPr>
@@ -5789,16 +5731,16 @@
           <a:p>
             <a:pPr>
               <a:lnSpc>
-                <a:spcPct val="115000"/>
+                <a:spcPct val="112000"/>
               </a:lnSpc>
               <a:spcAft>
-                <a:spcPts val="1400"/>
+                <a:spcPts val="1600"/>
               </a:spcAft>
             </a:pPr>
             <a:r>
-              <a:rPr sz="2600" b="1">
-                <a:solidFill>
-                  <a:srgbClr val="B50500"/>
+              <a:rPr sz="2600" b="1" spc="-50">
+                <a:solidFill>
+                  <a:srgbClr val="B30022"/>
                 </a:solidFill>
                 <a:latin typeface="Space Grotesk"/>
               </a:rPr>
@@ -5817,16 +5759,16 @@
           <a:p>
             <a:pPr>
               <a:lnSpc>
-                <a:spcPct val="115000"/>
+                <a:spcPct val="112000"/>
               </a:lnSpc>
               <a:spcAft>
-                <a:spcPts val="1400"/>
+                <a:spcPts val="1600"/>
               </a:spcAft>
             </a:pPr>
             <a:r>
-              <a:rPr sz="2600" b="1">
-                <a:solidFill>
-                  <a:srgbClr val="B50500"/>
+              <a:rPr sz="2600" b="1" spc="-50">
+                <a:solidFill>
+                  <a:srgbClr val="B30022"/>
                 </a:solidFill>
                 <a:latin typeface="Space Grotesk"/>
               </a:rPr>

</xml_diff>

<commit_message>
Rebuild Thursday deck from brand-sample-deck.pptx template (real brand), workshop topic
</commit_message>
<xml_diff>
--- a/working/context-ai-workshop-slides.pptx
+++ b/working/context-ai-workshop-slides.pptx
@@ -14,9 +14,6 @@
     <p:sldId id="262" r:id="rId13"/>
     <p:sldId id="263" r:id="rId14"/>
     <p:sldId id="264" r:id="rId15"/>
-    <p:sldId id="265" r:id="rId16"/>
-    <p:sldId id="266" r:id="rId17"/>
-    <p:sldId id="267" r:id="rId18"/>
   </p:sldIdLst>
   <p:sldSz cx="12191695" cy="6858000" type="screen4x3"/>
   <p:notesSz cx="6858000" cy="9144000"/>
@@ -3092,6 +3089,14 @@
 <file path=ppt/slides/slide1.xml><?xml version="1.0" encoding="utf-8"?>
 <p:sld xmlns:a="http://schemas.openxmlformats.org/drawingml/2006/main" xmlns:p="http://schemas.openxmlformats.org/presentationml/2006/main" xmlns:r="http://schemas.openxmlformats.org/officeDocument/2006/relationships">
   <p:cSld>
+    <p:bg>
+      <p:bgPr>
+        <a:solidFill>
+          <a:srgbClr val="E5E6E0"/>
+        </a:solidFill>
+        <a:effectLst/>
+      </p:bgPr>
+    </p:bg>
     <p:spTree>
       <p:nvGrpSpPr>
         <p:cNvPr id="1" name=""/>
@@ -3106,20 +3111,19 @@
           <p:nvPr/>
         </p:nvSpPr>
         <p:spPr>
-          <a:xfrm>
-            <a:off x="0" y="0"/>
-            <a:ext cx="12191695" cy="6858000"/>
-          </a:xfrm>
-          <a:prstGeom prst="rect">
-            <a:avLst/>
-          </a:prstGeom>
-          <a:solidFill>
-            <a:srgbClr val="18171F"/>
-          </a:solidFill>
-          <a:ln>
-            <a:noFill/>
+          <a:xfrm rot="21480000">
+            <a:off x="822960" y="914400"/>
+            <a:ext cx="2194560" cy="384048"/>
+          </a:xfrm>
+          <a:prstGeom prst="rect">
+            <a:avLst/>
+          </a:prstGeom>
+          <a:noFill/>
+          <a:ln w="19050">
+            <a:solidFill>
+              <a:srgbClr val="9E3E58"/>
+            </a:solidFill>
           </a:ln>
-          <a:effectLst/>
         </p:spPr>
         <p:style>
           <a:lnRef idx="1">
@@ -3136,10 +3140,19 @@
           </a:fontRef>
         </p:style>
         <p:txBody>
-          <a:bodyPr rtlCol="0" anchor="ctr"/>
+          <a:bodyPr rtlCol="0" anchor="ctr" lIns="109728" rIns="109728" tIns="36576" bIns="36576"/>
           <a:lstStyle/>
           <a:p>
             <a:pPr algn="ctr"/>
+            <a:r>
+              <a:rPr sz="1000" b="1" spc="200">
+                <a:solidFill>
+                  <a:srgbClr val="9E3E58"/>
+                </a:solidFill>
+                <a:latin typeface="Space Grotesk"/>
+              </a:rPr>
+              <a:t>AI WORKSHOP</a:t>
+            </a:r>
           </a:p>
         </p:txBody>
       </p:sp>
@@ -3151,8 +3164,8 @@
         </p:nvSpPr>
         <p:spPr>
           <a:xfrm>
-            <a:off x="822960" y="658368"/>
-            <a:ext cx="9144000" cy="640080"/>
+            <a:off x="822960" y="1554480"/>
+            <a:ext cx="7315200" cy="1005840"/>
           </a:xfrm>
           <a:prstGeom prst="rect">
             <a:avLst/>
@@ -3160,24 +3173,20 @@
           <a:noFill/>
         </p:spPr>
         <p:txBody>
-          <a:bodyPr wrap="square">
+          <a:bodyPr wrap="square" lIns="0" rIns="0" tIns="0" bIns="0">
             <a:spAutoFit/>
           </a:bodyPr>
           <a:lstStyle/>
           <a:p>
-            <a:pPr algn="l">
-              <a:lnSpc>
-                <a:spcPct val="110000"/>
-              </a:lnSpc>
-            </a:pPr>
-            <a:r>
-              <a:rPr sz="3200" b="1">
+            <a:pPr algn="l"/>
+            <a:r>
+              <a:rPr sz="4400" b="1" i="0">
                 <a:solidFill>
                   <a:srgbClr val="9E3E58"/>
                 </a:solidFill>
                 <a:latin typeface="Caveat"/>
               </a:rPr>
-              <a:t>grant writing accelerator, ai workshop</a:t>
+              <a:t>Before we build.</a:t>
             </a:r>
           </a:p>
         </p:txBody>
@@ -3190,8 +3199,8 @@
         </p:nvSpPr>
         <p:spPr>
           <a:xfrm>
-            <a:off x="822960" y="1737360"/>
-            <a:ext cx="10881360" cy="2468880"/>
+            <a:off x="822960" y="2560320"/>
+            <a:ext cx="10972800" cy="1645920"/>
           </a:xfrm>
           <a:prstGeom prst="rect">
             <a:avLst/>
@@ -3199,161 +3208,62 @@
           <a:noFill/>
         </p:spPr>
         <p:txBody>
-          <a:bodyPr wrap="square">
+          <a:bodyPr wrap="none" lIns="0" rIns="0" tIns="0" bIns="0">
             <a:spAutoFit/>
           </a:bodyPr>
           <a:lstStyle/>
           <a:p>
-            <a:pPr algn="l">
-              <a:lnSpc>
-                <a:spcPct val="100000"/>
-              </a:lnSpc>
-            </a:pPr>
-            <a:r>
-              <a:rPr sz="6200" b="1" spc="-200">
-                <a:solidFill>
-                  <a:srgbClr val="E5E6E0"/>
-                </a:solidFill>
-                <a:latin typeface="Space Grotesk"/>
-              </a:rPr>
-              <a:t>IT IS NOT THE AI.</a:t>
-            </a:r>
-          </a:p>
-          <a:p>
-            <a:pPr algn="l">
-              <a:lnSpc>
-                <a:spcPct val="100000"/>
-              </a:lnSpc>
-            </a:pPr>
-            <a:r>
-              <a:rPr sz="6200" b="1" spc="-200">
-                <a:solidFill>
-                  <a:srgbClr val="E5E6E0"/>
+            <a:pPr algn="l"/>
+            <a:r>
+              <a:rPr sz="9600" b="1" spc="-200">
+                <a:solidFill>
+                  <a:srgbClr val="18171F"/>
                 </a:solidFill>
                 <a:latin typeface="Space Grotesk"/>
               </a:rPr>
               <a:t>IT IS THE CONTEXT.</a:t>
             </a:r>
-          </a:p>
-        </p:txBody>
-      </p:sp>
-      <p:sp>
-        <p:nvSpPr>
-          <p:cNvPr id="5" name="TextBox 4"/>
-          <p:cNvSpPr txBox="1"/>
-          <p:nvPr/>
-        </p:nvSpPr>
-        <p:spPr>
-          <a:xfrm>
-            <a:off x="822960" y="4526280"/>
-            <a:ext cx="10058400" cy="731520"/>
-          </a:xfrm>
-          <a:prstGeom prst="rect">
-            <a:avLst/>
-          </a:prstGeom>
-          <a:noFill/>
-        </p:spPr>
-        <p:txBody>
-          <a:bodyPr wrap="square">
-            <a:spAutoFit/>
-          </a:bodyPr>
-          <a:lstStyle/>
-          <a:p>
-            <a:pPr algn="l">
-              <a:lnSpc>
-                <a:spcPct val="110000"/>
-              </a:lnSpc>
-            </a:pPr>
-            <a:r>
-              <a:rPr sz="3000" b="1">
+            <a:r>
+              <a:rPr sz="9600" b="1" spc="-200">
                 <a:solidFill>
                   <a:srgbClr val="B30022"/>
-                </a:solidFill>
-                <a:latin typeface="Caveat"/>
-              </a:rPr>
-              <a:t>a short conversation before we build.</a:t>
-            </a:r>
-          </a:p>
-        </p:txBody>
-      </p:sp>
-      <p:sp>
-        <p:nvSpPr>
-          <p:cNvPr id="6" name="TextBox 5"/>
-          <p:cNvSpPr txBox="1"/>
-          <p:nvPr/>
-        </p:nvSpPr>
-        <p:spPr>
-          <a:xfrm>
-            <a:off x="822960" y="6217920"/>
-            <a:ext cx="5486400" cy="365760"/>
-          </a:xfrm>
-          <a:prstGeom prst="rect">
-            <a:avLst/>
-          </a:prstGeom>
-          <a:noFill/>
-        </p:spPr>
-        <p:txBody>
-          <a:bodyPr wrap="square">
-            <a:spAutoFit/>
-          </a:bodyPr>
-          <a:lstStyle/>
-          <a:p>
-            <a:pPr algn="l">
-              <a:lnSpc>
-                <a:spcPct val="110000"/>
-              </a:lnSpc>
-            </a:pPr>
-            <a:r>
-              <a:rPr sz="1200" b="1" spc="150">
-                <a:solidFill>
-                  <a:srgbClr val="B9BAB4"/>
                 </a:solidFill>
                 <a:latin typeface="Space Grotesk"/>
               </a:rPr>
-              <a:t>ashleyscruse.com</a:t>
-            </a:r>
-          </a:p>
-        </p:txBody>
-      </p:sp>
-    </p:spTree>
-  </p:cSld>
-  <p:clrMapOvr>
-    <a:masterClrMapping/>
-  </p:clrMapOvr>
-</p:sld>
-</file>
-
-<file path=ppt/slides/slide10.xml><?xml version="1.0" encoding="utf-8"?>
-<p:sld xmlns:a="http://schemas.openxmlformats.org/drawingml/2006/main" xmlns:p="http://schemas.openxmlformats.org/presentationml/2006/main" xmlns:r="http://schemas.openxmlformats.org/officeDocument/2006/relationships">
-  <p:cSld>
-    <p:spTree>
-      <p:nvGrpSpPr>
-        <p:cNvPr id="1" name=""/>
-        <p:cNvGrpSpPr/>
-        <p:nvPr/>
-      </p:nvGrpSpPr>
-      <p:grpSpPr/>
-      <p:sp>
-        <p:nvSpPr>
-          <p:cNvPr id="2" name="Rectangle 1"/>
+              <a:t/>
+            </a:r>
+            <a:r>
+              <a:rPr sz="9600" b="1" spc="-200">
+                <a:solidFill>
+                  <a:srgbClr val="18171F"/>
+                </a:solidFill>
+                <a:latin typeface="Space Grotesk"/>
+              </a:rPr>
+              <a:t/>
+            </a:r>
+          </a:p>
+        </p:txBody>
+      </p:sp>
+      <p:sp>
+        <p:nvSpPr>
+          <p:cNvPr id="5" name="Rectangle 4"/>
           <p:cNvSpPr/>
           <p:nvPr/>
         </p:nvSpPr>
         <p:spPr>
           <a:xfrm>
-            <a:off x="0" y="0"/>
-            <a:ext cx="12191695" cy="6858000"/>
+            <a:off x="2788920" y="4297680"/>
+            <a:ext cx="6126480" cy="88900"/>
           </a:xfrm>
           <a:prstGeom prst="rect">
             <a:avLst/>
           </a:prstGeom>
           <a:solidFill>
-            <a:srgbClr val="E5E6E0"/>
+            <a:srgbClr val="B30022"/>
           </a:solidFill>
           <a:ln>
             <a:noFill/>
           </a:ln>
-          <a:effectLst/>
         </p:spPr>
         <p:style>
           <a:lnRef idx="1">
@@ -3379,14 +3289,14 @@
       </p:sp>
       <p:sp>
         <p:nvSpPr>
-          <p:cNvPr id="3" name="TextBox 2"/>
+          <p:cNvPr id="6" name="TextBox 5"/>
           <p:cNvSpPr txBox="1"/>
           <p:nvPr/>
         </p:nvSpPr>
         <p:spPr>
           <a:xfrm>
-            <a:off x="822960" y="658368"/>
-            <a:ext cx="9144000" cy="640080"/>
+            <a:off x="822960" y="4937760"/>
+            <a:ext cx="9144000" cy="1371600"/>
           </a:xfrm>
           <a:prstGeom prst="rect">
             <a:avLst/>
@@ -3394,38 +3304,34 @@
           <a:noFill/>
         </p:spPr>
         <p:txBody>
-          <a:bodyPr wrap="square">
+          <a:bodyPr wrap="square" lIns="0" rIns="0" tIns="0" bIns="0">
             <a:spAutoFit/>
           </a:bodyPr>
           <a:lstStyle/>
           <a:p>
-            <a:pPr algn="l">
-              <a:lnSpc>
-                <a:spcPct val="110000"/>
-              </a:lnSpc>
-            </a:pPr>
-            <a:r>
-              <a:rPr sz="3200" b="1">
-                <a:solidFill>
-                  <a:srgbClr val="9E3E58"/>
-                </a:solidFill>
-                <a:latin typeface="Caveat"/>
+            <a:pPr algn="l"/>
+            <a:r>
+              <a:rPr sz="1800" b="0" i="0">
+                <a:solidFill>
+                  <a:srgbClr val="3D3B47"/>
+                </a:solidFill>
+                <a:latin typeface="Outfit"/>
               </a:rPr>
-              <a:t>good habits</a:t>
-            </a:r>
-          </a:p>
-        </p:txBody>
-      </p:sp>
-      <p:sp>
-        <p:nvSpPr>
-          <p:cNvPr id="4" name="TextBox 3"/>
+              <a:t>It is not the AI, it is the context. A short conversation before we open the workspace and set up yours.</a:t>
+            </a:r>
+          </a:p>
+        </p:txBody>
+      </p:sp>
+      <p:sp>
+        <p:nvSpPr>
+          <p:cNvPr id="7" name="TextBox 6"/>
           <p:cNvSpPr txBox="1"/>
           <p:nvPr/>
         </p:nvSpPr>
         <p:spPr>
           <a:xfrm>
-            <a:off x="822960" y="1234440"/>
-            <a:ext cx="10607040" cy="1280160"/>
+            <a:off x="822960" y="6263640"/>
+            <a:ext cx="5486400" cy="320040"/>
           </a:xfrm>
           <a:prstGeom prst="rect">
             <a:avLst/>
@@ -3433,131 +3339,20 @@
           <a:noFill/>
         </p:spPr>
         <p:txBody>
-          <a:bodyPr wrap="square">
+          <a:bodyPr wrap="square" lIns="0" rIns="0" tIns="0" bIns="0">
             <a:spAutoFit/>
           </a:bodyPr>
           <a:lstStyle/>
           <a:p>
-            <a:pPr algn="l">
-              <a:lnSpc>
-                <a:spcPct val="103000"/>
-              </a:lnSpc>
-            </a:pPr>
-            <a:r>
-              <a:rPr sz="4200" b="1" spc="-150">
-                <a:solidFill>
-                  <a:srgbClr val="18171F"/>
+            <a:pPr algn="l"/>
+            <a:r>
+              <a:rPr sz="1000" b="1" i="0" spc="300">
+                <a:solidFill>
+                  <a:srgbClr val="9E3E58"/>
                 </a:solidFill>
                 <a:latin typeface="Space Grotesk"/>
               </a:rPr>
-              <a:t>You drive</a:t>
-            </a:r>
-          </a:p>
-        </p:txBody>
-      </p:sp>
-      <p:sp>
-        <p:nvSpPr>
-          <p:cNvPr id="5" name="TextBox 4"/>
-          <p:cNvSpPr txBox="1"/>
-          <p:nvPr/>
-        </p:nvSpPr>
-        <p:spPr>
-          <a:xfrm>
-            <a:off x="822960" y="2651760"/>
-            <a:ext cx="10607040" cy="3840480"/>
-          </a:xfrm>
-          <a:prstGeom prst="rect">
-            <a:avLst/>
-          </a:prstGeom>
-          <a:noFill/>
-        </p:spPr>
-        <p:txBody>
-          <a:bodyPr wrap="square">
-            <a:spAutoFit/>
-          </a:bodyPr>
-          <a:lstStyle/>
-          <a:p>
-            <a:pPr>
-              <a:lnSpc>
-                <a:spcPct val="112000"/>
-              </a:lnSpc>
-              <a:spcAft>
-                <a:spcPts val="1600"/>
-              </a:spcAft>
-            </a:pPr>
-            <a:r>
-              <a:rPr sz="2600" b="1" spc="-50">
-                <a:solidFill>
-                  <a:srgbClr val="B30022"/>
-                </a:solidFill>
-                <a:latin typeface="Space Grotesk"/>
-              </a:rPr>
-              <a:t>You decide.</a:t>
-            </a:r>
-            <a:r>
-              <a:rPr sz="2600">
-                <a:solidFill>
-                  <a:srgbClr val="18171F"/>
-                </a:solidFill>
-                <a:latin typeface="Outfit"/>
-              </a:rPr>
-              <a:t>  The AI accelerates; the judgment stays yours.</a:t>
-            </a:r>
-          </a:p>
-          <a:p>
-            <a:pPr>
-              <a:lnSpc>
-                <a:spcPct val="112000"/>
-              </a:lnSpc>
-              <a:spcAft>
-                <a:spcPts val="1600"/>
-              </a:spcAft>
-            </a:pPr>
-            <a:r>
-              <a:rPr sz="2600" b="1" spc="-50">
-                <a:solidFill>
-                  <a:srgbClr val="B30022"/>
-                </a:solidFill>
-                <a:latin typeface="Space Grotesk"/>
-              </a:rPr>
-              <a:t>Iterate.</a:t>
-            </a:r>
-            <a:r>
-              <a:rPr sz="2600">
-                <a:solidFill>
-                  <a:srgbClr val="18171F"/>
-                </a:solidFill>
-                <a:latin typeface="Outfit"/>
-              </a:rPr>
-              <a:t>  Draft, react, refine. The first pass is a starting point.</a:t>
-            </a:r>
-          </a:p>
-          <a:p>
-            <a:pPr>
-              <a:lnSpc>
-                <a:spcPct val="112000"/>
-              </a:lnSpc>
-              <a:spcAft>
-                <a:spcPts val="1600"/>
-              </a:spcAft>
-            </a:pPr>
-            <a:r>
-              <a:rPr sz="2600" b="1" spc="-50">
-                <a:solidFill>
-                  <a:srgbClr val="B30022"/>
-                </a:solidFill>
-                <a:latin typeface="Space Grotesk"/>
-              </a:rPr>
-              <a:t>Verify.</a:t>
-            </a:r>
-            <a:r>
-              <a:rPr sz="2600">
-                <a:solidFill>
-                  <a:srgbClr val="18171F"/>
-                </a:solidFill>
-                <a:latin typeface="Outfit"/>
-              </a:rPr>
-              <a:t>  Check every number, date, and name before it goes out.</a:t>
+              <a:t>ashleyscruse.com</a:t>
             </a:r>
           </a:p>
         </p:txBody>
@@ -3570,9 +3365,17 @@
 </p:sld>
 </file>
 
-<file path=ppt/slides/slide11.xml><?xml version="1.0" encoding="utf-8"?>
+<file path=ppt/slides/slide2.xml><?xml version="1.0" encoding="utf-8"?>
 <p:sld xmlns:a="http://schemas.openxmlformats.org/drawingml/2006/main" xmlns:p="http://schemas.openxmlformats.org/presentationml/2006/main" xmlns:r="http://schemas.openxmlformats.org/officeDocument/2006/relationships">
   <p:cSld>
+    <p:bg>
+      <p:bgPr>
+        <a:solidFill>
+          <a:srgbClr val="EDE7DF"/>
+        </a:solidFill>
+        <a:effectLst/>
+      </p:bgPr>
+    </p:bg>
     <p:spTree>
       <p:nvGrpSpPr>
         <p:cNvPr id="1" name=""/>
@@ -3582,25 +3385,129 @@
       <p:grpSpPr/>
       <p:sp>
         <p:nvSpPr>
-          <p:cNvPr id="2" name="Rectangle 1"/>
+          <p:cNvPr id="2" name="TextBox 1"/>
+          <p:cNvSpPr txBox="1"/>
+          <p:nvPr/>
+        </p:nvSpPr>
+        <p:spPr>
+          <a:xfrm>
+            <a:off x="457200" y="1463040"/>
+            <a:ext cx="11277295" cy="457200"/>
+          </a:xfrm>
+          <a:prstGeom prst="rect">
+            <a:avLst/>
+          </a:prstGeom>
+          <a:noFill/>
+        </p:spPr>
+        <p:txBody>
+          <a:bodyPr wrap="square" lIns="0" rIns="0" tIns="0" bIns="0">
+            <a:spAutoFit/>
+          </a:bodyPr>
+          <a:lstStyle/>
+          <a:p>
+            <a:pPr algn="ctr"/>
+            <a:r>
+              <a:rPr sz="1200" b="1" i="0" spc="400">
+                <a:solidFill>
+                  <a:srgbClr val="9E3E58"/>
+                </a:solidFill>
+                <a:latin typeface="Space Grotesk"/>
+              </a:rPr>
+              <a:t>PART ONE</a:t>
+            </a:r>
+          </a:p>
+        </p:txBody>
+      </p:sp>
+      <p:sp>
+        <p:nvSpPr>
+          <p:cNvPr id="3" name="TextBox 2"/>
+          <p:cNvSpPr txBox="1"/>
+          <p:nvPr/>
+        </p:nvSpPr>
+        <p:spPr>
+          <a:xfrm>
+            <a:off x="457200" y="2011680"/>
+            <a:ext cx="11277295" cy="1005840"/>
+          </a:xfrm>
+          <a:prstGeom prst="rect">
+            <a:avLst/>
+          </a:prstGeom>
+          <a:noFill/>
+        </p:spPr>
+        <p:txBody>
+          <a:bodyPr wrap="square" lIns="0" rIns="0" tIns="0" bIns="0">
+            <a:spAutoFit/>
+          </a:bodyPr>
+          <a:lstStyle/>
+          <a:p>
+            <a:pPr algn="ctr"/>
+            <a:r>
+              <a:rPr sz="4800" b="1" i="0">
+                <a:solidFill>
+                  <a:srgbClr val="9E3E58"/>
+                </a:solidFill>
+                <a:latin typeface="Caveat"/>
+              </a:rPr>
+              <a:t>Where we start.</a:t>
+            </a:r>
+          </a:p>
+        </p:txBody>
+      </p:sp>
+      <p:sp>
+        <p:nvSpPr>
+          <p:cNvPr id="4" name="TextBox 3"/>
+          <p:cNvSpPr txBox="1"/>
+          <p:nvPr/>
+        </p:nvSpPr>
+        <p:spPr>
+          <a:xfrm>
+            <a:off x="457200" y="3108960"/>
+            <a:ext cx="11277295" cy="1828800"/>
+          </a:xfrm>
+          <a:prstGeom prst="rect">
+            <a:avLst/>
+          </a:prstGeom>
+          <a:noFill/>
+        </p:spPr>
+        <p:txBody>
+          <a:bodyPr wrap="square" lIns="0" rIns="0" tIns="0" bIns="0">
+            <a:spAutoFit/>
+          </a:bodyPr>
+          <a:lstStyle/>
+          <a:p>
+            <a:pPr algn="ctr"/>
+            <a:r>
+              <a:rPr sz="10800" b="1" i="0" spc="-200">
+                <a:solidFill>
+                  <a:srgbClr val="18171F"/>
+                </a:solidFill>
+                <a:latin typeface="Space Grotesk"/>
+              </a:rPr>
+              <a:t>THE PROBLEM.</a:t>
+            </a:r>
+          </a:p>
+        </p:txBody>
+      </p:sp>
+      <p:sp>
+        <p:nvSpPr>
+          <p:cNvPr id="5" name="Rectangle 4"/>
           <p:cNvSpPr/>
           <p:nvPr/>
         </p:nvSpPr>
         <p:spPr>
           <a:xfrm>
-            <a:off x="0" y="0"/>
-            <a:ext cx="12191695" cy="6858000"/>
+            <a:off x="4952847" y="5212080"/>
+            <a:ext cx="2286000" cy="38100"/>
           </a:xfrm>
           <a:prstGeom prst="rect">
             <a:avLst/>
           </a:prstGeom>
           <a:solidFill>
-            <a:srgbClr val="18171F"/>
+            <a:srgbClr val="9E3E58"/>
           </a:solidFill>
           <a:ln>
             <a:noFill/>
           </a:ln>
-          <a:effectLst/>
         </p:spPr>
         <p:style>
           <a:lnRef idx="1">
@@ -3624,27 +3531,52 @@
           </a:p>
         </p:txBody>
       </p:sp>
-      <p:sp>
-        <p:nvSpPr>
-          <p:cNvPr id="3" name="Rectangle 2"/>
+    </p:spTree>
+  </p:cSld>
+  <p:clrMapOvr>
+    <a:masterClrMapping/>
+  </p:clrMapOvr>
+</p:sld>
+</file>
+
+<file path=ppt/slides/slide3.xml><?xml version="1.0" encoding="utf-8"?>
+<p:sld xmlns:a="http://schemas.openxmlformats.org/drawingml/2006/main" xmlns:p="http://schemas.openxmlformats.org/presentationml/2006/main" xmlns:r="http://schemas.openxmlformats.org/officeDocument/2006/relationships">
+  <p:cSld>
+    <p:bg>
+      <p:bgPr>
+        <a:solidFill>
+          <a:srgbClr val="E5E6E0"/>
+        </a:solidFill>
+        <a:effectLst/>
+      </p:bgPr>
+    </p:bg>
+    <p:spTree>
+      <p:nvGrpSpPr>
+        <p:cNvPr id="1" name=""/>
+        <p:cNvGrpSpPr/>
+        <p:nvPr/>
+      </p:nvGrpSpPr>
+      <p:grpSpPr/>
+      <p:sp>
+        <p:nvSpPr>
+          <p:cNvPr id="2" name="Rectangle 1"/>
           <p:cNvSpPr/>
           <p:nvPr/>
         </p:nvSpPr>
         <p:spPr>
-          <a:xfrm>
-            <a:off x="822960" y="1371600"/>
-            <a:ext cx="1371600" cy="82296"/>
-          </a:xfrm>
-          <a:prstGeom prst="rect">
-            <a:avLst/>
-          </a:prstGeom>
-          <a:solidFill>
-            <a:srgbClr val="B30022"/>
-          </a:solidFill>
-          <a:ln>
-            <a:noFill/>
+          <a:xfrm rot="21480000">
+            <a:off x="822960" y="914400"/>
+            <a:ext cx="2194560" cy="384048"/>
+          </a:xfrm>
+          <a:prstGeom prst="rect">
+            <a:avLst/>
+          </a:prstGeom>
+          <a:noFill/>
+          <a:ln w="19050">
+            <a:solidFill>
+              <a:srgbClr val="9E3E58"/>
+            </a:solidFill>
           </a:ln>
-          <a:effectLst/>
         </p:spPr>
         <p:style>
           <a:lnRef idx="1">
@@ -3661,10 +3593,54 @@
           </a:fontRef>
         </p:style>
         <p:txBody>
-          <a:bodyPr rtlCol="0" anchor="ctr"/>
+          <a:bodyPr rtlCol="0" anchor="ctr" lIns="109728" rIns="109728" tIns="36576" bIns="36576"/>
           <a:lstStyle/>
           <a:p>
             <a:pPr algn="ctr"/>
+            <a:r>
+              <a:rPr sz="1000" b="1" spc="200">
+                <a:solidFill>
+                  <a:srgbClr val="9E3E58"/>
+                </a:solidFill>
+                <a:latin typeface="Space Grotesk"/>
+              </a:rPr>
+              <a:t>THE STORY</a:t>
+            </a:r>
+          </a:p>
+        </p:txBody>
+      </p:sp>
+      <p:sp>
+        <p:nvSpPr>
+          <p:cNvPr id="3" name="TextBox 2"/>
+          <p:cNvSpPr txBox="1"/>
+          <p:nvPr/>
+        </p:nvSpPr>
+        <p:spPr>
+          <a:xfrm>
+            <a:off x="822960" y="1554480"/>
+            <a:ext cx="6858000" cy="914400"/>
+          </a:xfrm>
+          <a:prstGeom prst="rect">
+            <a:avLst/>
+          </a:prstGeom>
+          <a:noFill/>
+        </p:spPr>
+        <p:txBody>
+          <a:bodyPr wrap="square" lIns="0" rIns="0" tIns="0" bIns="0">
+            <a:spAutoFit/>
+          </a:bodyPr>
+          <a:lstStyle/>
+          <a:p>
+            <a:pPr algn="l"/>
+            <a:r>
+              <a:rPr sz="4000" b="1" i="0">
+                <a:solidFill>
+                  <a:srgbClr val="9E3E58"/>
+                </a:solidFill>
+                <a:latin typeface="Caveat"/>
+              </a:rPr>
+              <a:t>It's not you.</a:t>
+            </a:r>
           </a:p>
         </p:txBody>
       </p:sp>
@@ -3676,8 +3652,8 @@
         </p:nvSpPr>
         <p:spPr>
           <a:xfrm>
-            <a:off x="822960" y="1600200"/>
-            <a:ext cx="10607040" cy="1280160"/>
+            <a:off x="822960" y="2377440"/>
+            <a:ext cx="6858000" cy="2103120"/>
           </a:xfrm>
           <a:prstGeom prst="rect">
             <a:avLst/>
@@ -3685,24 +3661,25 @@
           <a:noFill/>
         </p:spPr>
         <p:txBody>
-          <a:bodyPr wrap="square">
+          <a:bodyPr wrap="square" lIns="0" rIns="0" tIns="0" bIns="0">
             <a:spAutoFit/>
           </a:bodyPr>
           <a:lstStyle/>
           <a:p>
-            <a:pPr algn="l">
-              <a:lnSpc>
-                <a:spcPct val="103000"/>
-              </a:lnSpc>
-            </a:pPr>
-            <a:r>
-              <a:rPr sz="4000" b="1" spc="-150">
-                <a:solidFill>
-                  <a:srgbClr val="E5E6E0"/>
+            <a:pPr algn="l"/>
+            <a:r>
+              <a:rPr sz="5200" b="1" i="0" spc="-150">
+                <a:solidFill>
+                  <a:srgbClr val="18171F"/>
                 </a:solidFill>
                 <a:latin typeface="Space Grotesk"/>
               </a:rPr>
-              <a:t>This is how the workspace works</a:t>
+              <a:t>EVERY CONVERSATION</a:t>
+            </a:r>
+          </a:p>
+          <a:p>
+            <a:r>
+              <a:t>STARTS AT ZERO.</a:t>
             </a:r>
           </a:p>
         </p:txBody>
@@ -3715,8 +3692,8 @@
         </p:nvSpPr>
         <p:spPr>
           <a:xfrm>
-            <a:off x="822960" y="3063240"/>
-            <a:ext cx="10424160" cy="1828800"/>
+            <a:off x="822960" y="4572000"/>
+            <a:ext cx="6858000" cy="1828800"/>
           </a:xfrm>
           <a:prstGeom prst="rect">
             <a:avLst/>
@@ -3724,24 +3701,65 @@
           <a:noFill/>
         </p:spPr>
         <p:txBody>
-          <a:bodyPr wrap="square">
+          <a:bodyPr wrap="square" lIns="0" rIns="0" tIns="0" bIns="0">
             <a:spAutoFit/>
           </a:bodyPr>
           <a:lstStyle/>
           <a:p>
-            <a:pPr algn="l">
-              <a:lnSpc>
-                <a:spcPct val="130000"/>
-              </a:lnSpc>
-            </a:pPr>
-            <a:r>
-              <a:rPr sz="2800" b="0">
-                <a:solidFill>
-                  <a:srgbClr val="B9BAB4"/>
+            <a:pPr algn="l"/>
+            <a:r>
+              <a:rPr sz="1700" b="0" i="0">
+                <a:solidFill>
+                  <a:srgbClr val="3D3B47"/>
                 </a:solidFill>
                 <a:latin typeface="Outfit"/>
               </a:rPr>
-              <a:t>Context in, grounded help out. You are about to open a workspace built on exactly these ideas.</a:t>
+              <a:t>You sit down to work. You open the AI and start re-explaining who you are and what you are doing, because it has no memory of you. Ten minutes later you finally get help, and it is generic.</a:t>
+            </a:r>
+          </a:p>
+        </p:txBody>
+      </p:sp>
+      <p:sp>
+        <p:nvSpPr>
+          <p:cNvPr id="6" name="TextBox 5"/>
+          <p:cNvSpPr txBox="1"/>
+          <p:nvPr/>
+        </p:nvSpPr>
+        <p:spPr>
+          <a:xfrm>
+            <a:off x="8229600" y="1645920"/>
+            <a:ext cx="3657600" cy="5029200"/>
+          </a:xfrm>
+          <a:prstGeom prst="rect">
+            <a:avLst/>
+          </a:prstGeom>
+          <a:noFill/>
+        </p:spPr>
+        <p:txBody>
+          <a:bodyPr wrap="square" lIns="0" rIns="0" tIns="0" bIns="0">
+            <a:spAutoFit/>
+          </a:bodyPr>
+          <a:lstStyle/>
+          <a:p>
+            <a:pPr algn="l"/>
+            <a:r>
+              <a:rPr sz="8400" b="1" i="0">
+                <a:solidFill>
+                  <a:srgbClr val="B30022"/>
+                </a:solidFill>
+                <a:latin typeface="Caveat"/>
+              </a:rPr>
+              <a:t>you're</a:t>
+            </a:r>
+          </a:p>
+          <a:p>
+            <a:r>
+              <a:t>not</a:t>
+            </a:r>
+          </a:p>
+          <a:p>
+            <a:r>
+              <a:t>alone.</a:t>
             </a:r>
           </a:p>
         </p:txBody>
@@ -3754,9 +3772,17 @@
 </p:sld>
 </file>
 
-<file path=ppt/slides/slide12.xml><?xml version="1.0" encoding="utf-8"?>
+<file path=ppt/slides/slide4.xml><?xml version="1.0" encoding="utf-8"?>
 <p:sld xmlns:a="http://schemas.openxmlformats.org/drawingml/2006/main" xmlns:p="http://schemas.openxmlformats.org/presentationml/2006/main" xmlns:r="http://schemas.openxmlformats.org/officeDocument/2006/relationships">
   <p:cSld>
+    <p:bg>
+      <p:bgPr>
+        <a:solidFill>
+          <a:srgbClr val="EDE7DF"/>
+        </a:solidFill>
+        <a:effectLst/>
+      </p:bgPr>
+    </p:bg>
     <p:spTree>
       <p:nvGrpSpPr>
         <p:cNvPr id="1" name=""/>
@@ -3766,25 +3792,96 @@
       <p:grpSpPr/>
       <p:sp>
         <p:nvSpPr>
-          <p:cNvPr id="2" name="Rectangle 1"/>
+          <p:cNvPr id="2" name="TextBox 1"/>
+          <p:cNvSpPr txBox="1"/>
+          <p:nvPr/>
+        </p:nvSpPr>
+        <p:spPr>
+          <a:xfrm>
+            <a:off x="822960" y="640080"/>
+            <a:ext cx="9144000" cy="731520"/>
+          </a:xfrm>
+          <a:prstGeom prst="rect">
+            <a:avLst/>
+          </a:prstGeom>
+          <a:noFill/>
+        </p:spPr>
+        <p:txBody>
+          <a:bodyPr wrap="square" lIns="0" rIns="0" tIns="0" bIns="0">
+            <a:spAutoFit/>
+          </a:bodyPr>
+          <a:lstStyle/>
+          <a:p>
+            <a:pPr algn="l"/>
+            <a:r>
+              <a:rPr sz="3400" b="1" i="0">
+                <a:solidFill>
+                  <a:srgbClr val="9E3E58"/>
+                </a:solidFill>
+                <a:latin typeface="Caveat"/>
+              </a:rPr>
+              <a:t>Three at a glance.</a:t>
+            </a:r>
+          </a:p>
+        </p:txBody>
+      </p:sp>
+      <p:sp>
+        <p:nvSpPr>
+          <p:cNvPr id="3" name="TextBox 2"/>
+          <p:cNvSpPr txBox="1"/>
+          <p:nvPr/>
+        </p:nvSpPr>
+        <p:spPr>
+          <a:xfrm>
+            <a:off x="822960" y="1280160"/>
+            <a:ext cx="10058400" cy="1280160"/>
+          </a:xfrm>
+          <a:prstGeom prst="rect">
+            <a:avLst/>
+          </a:prstGeom>
+          <a:noFill/>
+        </p:spPr>
+        <p:txBody>
+          <a:bodyPr wrap="square" lIns="0" rIns="0" tIns="0" bIns="0">
+            <a:spAutoFit/>
+          </a:bodyPr>
+          <a:lstStyle/>
+          <a:p>
+            <a:pPr algn="l"/>
+            <a:r>
+              <a:rPr sz="5600" b="1" i="0" spc="-150">
+                <a:solidFill>
+                  <a:srgbClr val="18171F"/>
+                </a:solidFill>
+                <a:latin typeface="Space Grotesk"/>
+              </a:rPr>
+              <a:t>THE WORDS.</a:t>
+            </a:r>
+          </a:p>
+        </p:txBody>
+      </p:sp>
+      <p:sp>
+        <p:nvSpPr>
+          <p:cNvPr id="4" name="Rectangle 3"/>
           <p:cNvSpPr/>
           <p:nvPr/>
         </p:nvSpPr>
         <p:spPr>
-          <a:xfrm>
-            <a:off x="0" y="0"/>
-            <a:ext cx="12191695" cy="6858000"/>
+          <a:xfrm rot="21510000">
+            <a:off x="700887" y="2926080"/>
+            <a:ext cx="3383280" cy="3291840"/>
           </a:xfrm>
           <a:prstGeom prst="rect">
             <a:avLst/>
           </a:prstGeom>
           <a:solidFill>
-            <a:srgbClr val="18171F"/>
+            <a:srgbClr val="FFFFFF"/>
           </a:solidFill>
-          <a:ln>
-            <a:noFill/>
+          <a:ln w="6350">
+            <a:solidFill>
+              <a:srgbClr val="E0DAD2"/>
+            </a:solidFill>
           </a:ln>
-          <a:effectLst/>
         </p:spPr>
         <p:style>
           <a:lnRef idx="1">
@@ -3810,14 +3907,14 @@
       </p:sp>
       <p:sp>
         <p:nvSpPr>
-          <p:cNvPr id="3" name="TextBox 2"/>
+          <p:cNvPr id="5" name="TextBox 4"/>
           <p:cNvSpPr txBox="1"/>
           <p:nvPr/>
         </p:nvSpPr>
         <p:spPr>
-          <a:xfrm>
-            <a:off x="822960" y="658368"/>
-            <a:ext cx="9144000" cy="640080"/>
+          <a:xfrm rot="21510000">
+            <a:off x="1020927" y="3063240"/>
+            <a:ext cx="2011680" cy="1463040"/>
           </a:xfrm>
           <a:prstGeom prst="rect">
             <a:avLst/>
@@ -3825,161 +3922,44 @@
           <a:noFill/>
         </p:spPr>
         <p:txBody>
-          <a:bodyPr wrap="square">
+          <a:bodyPr wrap="square" lIns="0" rIns="0" tIns="0" bIns="0">
             <a:spAutoFit/>
           </a:bodyPr>
           <a:lstStyle/>
           <a:p>
-            <a:pPr algn="l">
-              <a:lnSpc>
-                <a:spcPct val="110000"/>
-              </a:lnSpc>
-            </a:pPr>
-            <a:r>
-              <a:rPr sz="3200" b="1">
-                <a:solidFill>
-                  <a:srgbClr val="B30022"/>
-                </a:solidFill>
-                <a:latin typeface="Caveat"/>
-              </a:rPr>
-              <a:t>let's build.</a:t>
-            </a:r>
-          </a:p>
-        </p:txBody>
-      </p:sp>
-      <p:sp>
-        <p:nvSpPr>
-          <p:cNvPr id="4" name="TextBox 3"/>
-          <p:cNvSpPr txBox="1"/>
-          <p:nvPr/>
-        </p:nvSpPr>
-        <p:spPr>
-          <a:xfrm>
-            <a:off x="822960" y="1920240"/>
-            <a:ext cx="10881360" cy="2468880"/>
-          </a:xfrm>
-          <a:prstGeom prst="rect">
-            <a:avLst/>
-          </a:prstGeom>
-          <a:noFill/>
-        </p:spPr>
-        <p:txBody>
-          <a:bodyPr wrap="square">
-            <a:spAutoFit/>
-          </a:bodyPr>
-          <a:lstStyle/>
-          <a:p>
-            <a:pPr algn="l">
-              <a:lnSpc>
-                <a:spcPct val="105000"/>
-              </a:lnSpc>
-            </a:pPr>
-            <a:r>
-              <a:rPr sz="5000" b="1" spc="-200">
-                <a:solidFill>
-                  <a:srgbClr val="E5E6E0"/>
+            <a:pPr algn="l"/>
+            <a:r>
+              <a:rPr sz="8000" b="1" i="0">
+                <a:solidFill>
+                  <a:srgbClr val="E2CACE"/>
                 </a:solidFill>
                 <a:latin typeface="Space Grotesk"/>
               </a:rPr>
-              <a:t>Fill in your context once.</a:t>
-            </a:r>
-          </a:p>
-          <a:p>
-            <a:pPr algn="l">
-              <a:lnSpc>
-                <a:spcPct val="105000"/>
-              </a:lnSpc>
-            </a:pPr>
-            <a:r>
-              <a:rPr sz="5000" b="1" spc="-200">
-                <a:solidFill>
-                  <a:srgbClr val="E5E6E0"/>
-                </a:solidFill>
-                <a:latin typeface="Space Grotesk"/>
-              </a:rPr>
-              <a:t>Reuse it on every proposal.</a:t>
-            </a:r>
-          </a:p>
-        </p:txBody>
-      </p:sp>
-      <p:sp>
-        <p:nvSpPr>
-          <p:cNvPr id="5" name="TextBox 4"/>
-          <p:cNvSpPr txBox="1"/>
-          <p:nvPr/>
-        </p:nvSpPr>
-        <p:spPr>
-          <a:xfrm>
-            <a:off x="822960" y="6217920"/>
-            <a:ext cx="5486400" cy="365760"/>
-          </a:xfrm>
-          <a:prstGeom prst="rect">
-            <a:avLst/>
-          </a:prstGeom>
-          <a:noFill/>
-        </p:spPr>
-        <p:txBody>
-          <a:bodyPr wrap="square">
-            <a:spAutoFit/>
-          </a:bodyPr>
-          <a:lstStyle/>
-          <a:p>
-            <a:pPr algn="l">
-              <a:lnSpc>
-                <a:spcPct val="110000"/>
-              </a:lnSpc>
-            </a:pPr>
-            <a:r>
-              <a:rPr sz="1200" b="1" spc="150">
-                <a:solidFill>
-                  <a:srgbClr val="B9BAB4"/>
-                </a:solidFill>
-                <a:latin typeface="Space Grotesk"/>
-              </a:rPr>
-              <a:t>ashleyscruse.com</a:t>
-            </a:r>
-          </a:p>
-        </p:txBody>
-      </p:sp>
-    </p:spTree>
-  </p:cSld>
-  <p:clrMapOvr>
-    <a:masterClrMapping/>
-  </p:clrMapOvr>
-</p:sld>
-</file>
-
-<file path=ppt/slides/slide2.xml><?xml version="1.0" encoding="utf-8"?>
-<p:sld xmlns:a="http://schemas.openxmlformats.org/drawingml/2006/main" xmlns:p="http://schemas.openxmlformats.org/presentationml/2006/main" xmlns:r="http://schemas.openxmlformats.org/officeDocument/2006/relationships">
-  <p:cSld>
-    <p:spTree>
-      <p:nvGrpSpPr>
-        <p:cNvPr id="1" name=""/>
-        <p:cNvGrpSpPr/>
-        <p:nvPr/>
-      </p:nvGrpSpPr>
-      <p:grpSpPr/>
-      <p:sp>
-        <p:nvSpPr>
-          <p:cNvPr id="2" name="Rectangle 1"/>
+              <a:t>01</a:t>
+            </a:r>
+          </a:p>
+        </p:txBody>
+      </p:sp>
+      <p:sp>
+        <p:nvSpPr>
+          <p:cNvPr id="6" name="Rectangle 5"/>
           <p:cNvSpPr/>
           <p:nvPr/>
         </p:nvSpPr>
         <p:spPr>
-          <a:xfrm>
-            <a:off x="0" y="0"/>
-            <a:ext cx="12191695" cy="6858000"/>
+          <a:xfrm rot="21510000">
+            <a:off x="1020927" y="4297680"/>
+            <a:ext cx="960120" cy="292608"/>
           </a:xfrm>
           <a:prstGeom prst="rect">
             <a:avLst/>
           </a:prstGeom>
           <a:solidFill>
-            <a:srgbClr val="E5E6E0"/>
+            <a:srgbClr val="9E3E58"/>
           </a:solidFill>
           <a:ln>
             <a:noFill/>
           </a:ln>
-          <a:effectLst/>
         </p:spPr>
         <p:style>
           <a:lnRef idx="1">
@@ -3996,23 +3976,32 @@
           </a:fontRef>
         </p:style>
         <p:txBody>
-          <a:bodyPr rtlCol="0" anchor="ctr"/>
+          <a:bodyPr rtlCol="0" anchor="ctr" lIns="54864" rIns="54864" tIns="18288" bIns="18288"/>
           <a:lstStyle/>
           <a:p>
             <a:pPr algn="ctr"/>
-          </a:p>
-        </p:txBody>
-      </p:sp>
-      <p:sp>
-        <p:nvSpPr>
-          <p:cNvPr id="3" name="TextBox 2"/>
+            <a:r>
+              <a:rPr sz="800" b="1" spc="300">
+                <a:solidFill>
+                  <a:srgbClr val="E5E6E0"/>
+                </a:solidFill>
+                <a:latin typeface="Space Grotesk"/>
+              </a:rPr>
+              <a:t>TERM</a:t>
+            </a:r>
+          </a:p>
+        </p:txBody>
+      </p:sp>
+      <p:sp>
+        <p:nvSpPr>
+          <p:cNvPr id="7" name="TextBox 6"/>
           <p:cNvSpPr txBox="1"/>
           <p:nvPr/>
         </p:nvSpPr>
         <p:spPr>
-          <a:xfrm>
-            <a:off x="822960" y="658368"/>
-            <a:ext cx="9144000" cy="640080"/>
+          <a:xfrm rot="21510000">
+            <a:off x="1020927" y="4709160"/>
+            <a:ext cx="2743200" cy="548640"/>
           </a:xfrm>
           <a:prstGeom prst="rect">
             <a:avLst/>
@@ -4020,38 +4009,34 @@
           <a:noFill/>
         </p:spPr>
         <p:txBody>
-          <a:bodyPr wrap="square">
+          <a:bodyPr wrap="square" lIns="0" rIns="0" tIns="0" bIns="0">
             <a:spAutoFit/>
           </a:bodyPr>
           <a:lstStyle/>
           <a:p>
-            <a:pPr algn="l">
-              <a:lnSpc>
-                <a:spcPct val="110000"/>
-              </a:lnSpc>
-            </a:pPr>
-            <a:r>
-              <a:rPr sz="3200" b="1">
-                <a:solidFill>
-                  <a:srgbClr val="9E3E58"/>
-                </a:solidFill>
-                <a:latin typeface="Caveat"/>
+            <a:pPr algn="l"/>
+            <a:r>
+              <a:rPr sz="2200" b="1" i="0">
+                <a:solidFill>
+                  <a:srgbClr val="18171F"/>
+                </a:solidFill>
+                <a:latin typeface="Space Grotesk"/>
               </a:rPr>
-              <a:t>the problem</a:t>
-            </a:r>
-          </a:p>
-        </p:txBody>
-      </p:sp>
-      <p:sp>
-        <p:nvSpPr>
-          <p:cNvPr id="4" name="TextBox 3"/>
+              <a:t>AI vs LLM</a:t>
+            </a:r>
+          </a:p>
+        </p:txBody>
+      </p:sp>
+      <p:sp>
+        <p:nvSpPr>
+          <p:cNvPr id="8" name="TextBox 7"/>
           <p:cNvSpPr txBox="1"/>
           <p:nvPr/>
         </p:nvSpPr>
         <p:spPr>
-          <a:xfrm>
-            <a:off x="822960" y="1234440"/>
-            <a:ext cx="10607040" cy="1280160"/>
+          <a:xfrm rot="21510000">
+            <a:off x="1020927" y="5257800"/>
+            <a:ext cx="2743200" cy="914400"/>
           </a:xfrm>
           <a:prstGeom prst="rect">
             <a:avLst/>
@@ -4059,106 +4044,46 @@
           <a:noFill/>
         </p:spPr>
         <p:txBody>
-          <a:bodyPr wrap="square">
+          <a:bodyPr wrap="square" lIns="0" rIns="0" tIns="0" bIns="0">
             <a:spAutoFit/>
           </a:bodyPr>
           <a:lstStyle/>
           <a:p>
-            <a:pPr algn="l">
-              <a:lnSpc>
-                <a:spcPct val="103000"/>
-              </a:lnSpc>
-            </a:pPr>
-            <a:r>
-              <a:rPr sz="4200" b="1" spc="-150">
-                <a:solidFill>
-                  <a:srgbClr val="18171F"/>
-                </a:solidFill>
-                <a:latin typeface="Space Grotesk"/>
-              </a:rPr>
-              <a:t>Generic in, generic out</a:t>
-            </a:r>
-          </a:p>
-        </p:txBody>
-      </p:sp>
-      <p:sp>
-        <p:nvSpPr>
-          <p:cNvPr id="5" name="TextBox 4"/>
-          <p:cNvSpPr txBox="1"/>
-          <p:nvPr/>
-        </p:nvSpPr>
-        <p:spPr>
-          <a:xfrm>
-            <a:off x="822960" y="2651760"/>
-            <a:ext cx="10424160" cy="2743200"/>
-          </a:xfrm>
-          <a:prstGeom prst="rect">
-            <a:avLst/>
-          </a:prstGeom>
-          <a:noFill/>
-        </p:spPr>
-        <p:txBody>
-          <a:bodyPr wrap="square">
-            <a:spAutoFit/>
-          </a:bodyPr>
-          <a:lstStyle/>
-          <a:p>
-            <a:pPr algn="l">
-              <a:lnSpc>
-                <a:spcPct val="130000"/>
-              </a:lnSpc>
-            </a:pPr>
-            <a:r>
-              <a:rPr sz="2700" b="0">
-                <a:solidFill>
-                  <a:srgbClr val="18171F"/>
+            <a:pPr algn="l"/>
+            <a:r>
+              <a:rPr sz="1300" b="0" i="0">
+                <a:solidFill>
+                  <a:srgbClr val="3D3B47"/>
                 </a:solidFill>
                 <a:latin typeface="Outfit"/>
               </a:rPr>
-              <a:t>Most people paste a question into a chat box and get generic help, because the tool has no idea who they are. It guesses from the average of the internet, and you spend the next hour correcting it.</a:t>
-            </a:r>
-          </a:p>
-        </p:txBody>
-      </p:sp>
-    </p:spTree>
-  </p:cSld>
-  <p:clrMapOvr>
-    <a:masterClrMapping/>
-  </p:clrMapOvr>
-</p:sld>
-</file>
-
-<file path=ppt/slides/slide3.xml><?xml version="1.0" encoding="utf-8"?>
-<p:sld xmlns:a="http://schemas.openxmlformats.org/drawingml/2006/main" xmlns:p="http://schemas.openxmlformats.org/presentationml/2006/main" xmlns:r="http://schemas.openxmlformats.org/officeDocument/2006/relationships">
-  <p:cSld>
-    <p:spTree>
-      <p:nvGrpSpPr>
-        <p:cNvPr id="1" name=""/>
-        <p:cNvGrpSpPr/>
-        <p:nvPr/>
-      </p:nvGrpSpPr>
-      <p:grpSpPr/>
-      <p:sp>
-        <p:nvSpPr>
-          <p:cNvPr id="2" name="Rectangle 1"/>
+              <a:t>AI is the field. An LLM is the text-trained model we actually use.</a:t>
+            </a:r>
+          </a:p>
+        </p:txBody>
+      </p:sp>
+      <p:sp>
+        <p:nvSpPr>
+          <p:cNvPr id="9" name="Rectangle 8"/>
           <p:cNvSpPr/>
           <p:nvPr/>
         </p:nvSpPr>
         <p:spPr>
-          <a:xfrm>
-            <a:off x="0" y="0"/>
-            <a:ext cx="12191695" cy="6858000"/>
+          <a:xfrm rot="90000">
+            <a:off x="4404207" y="2926080"/>
+            <a:ext cx="3383280" cy="3291840"/>
           </a:xfrm>
           <a:prstGeom prst="rect">
             <a:avLst/>
           </a:prstGeom>
           <a:solidFill>
-            <a:srgbClr val="E5E6E0"/>
+            <a:srgbClr val="FFFFFF"/>
           </a:solidFill>
-          <a:ln>
-            <a:noFill/>
+          <a:ln w="6350">
+            <a:solidFill>
+              <a:srgbClr val="E0DAD2"/>
+            </a:solidFill>
           </a:ln>
-          <a:effectLst/>
         </p:spPr>
         <p:style>
           <a:lnRef idx="1">
@@ -4184,14 +4109,14 @@
       </p:sp>
       <p:sp>
         <p:nvSpPr>
-          <p:cNvPr id="3" name="TextBox 2"/>
+          <p:cNvPr id="10" name="TextBox 9"/>
           <p:cNvSpPr txBox="1"/>
           <p:nvPr/>
         </p:nvSpPr>
         <p:spPr>
-          <a:xfrm>
-            <a:off x="822960" y="658368"/>
-            <a:ext cx="9144000" cy="640080"/>
+          <a:xfrm rot="90000">
+            <a:off x="4724247" y="3063240"/>
+            <a:ext cx="2011680" cy="1463040"/>
           </a:xfrm>
           <a:prstGeom prst="rect">
             <a:avLst/>
@@ -4199,145 +4124,44 @@
           <a:noFill/>
         </p:spPr>
         <p:txBody>
-          <a:bodyPr wrap="square">
+          <a:bodyPr wrap="square" lIns="0" rIns="0" tIns="0" bIns="0">
             <a:spAutoFit/>
           </a:bodyPr>
           <a:lstStyle/>
           <a:p>
-            <a:pPr algn="l">
-              <a:lnSpc>
-                <a:spcPct val="110000"/>
-              </a:lnSpc>
-            </a:pPr>
-            <a:r>
-              <a:rPr sz="3200" b="1">
-                <a:solidFill>
-                  <a:srgbClr val="9E3E58"/>
-                </a:solidFill>
-                <a:latin typeface="Caveat"/>
-              </a:rPr>
-              <a:t>the fix</a:t>
-            </a:r>
-          </a:p>
-        </p:txBody>
-      </p:sp>
-      <p:sp>
-        <p:nvSpPr>
-          <p:cNvPr id="4" name="TextBox 3"/>
-          <p:cNvSpPr txBox="1"/>
-          <p:nvPr/>
-        </p:nvSpPr>
-        <p:spPr>
-          <a:xfrm>
-            <a:off x="822960" y="1234440"/>
-            <a:ext cx="10607040" cy="1280160"/>
-          </a:xfrm>
-          <a:prstGeom prst="rect">
-            <a:avLst/>
-          </a:prstGeom>
-          <a:noFill/>
-        </p:spPr>
-        <p:txBody>
-          <a:bodyPr wrap="square">
-            <a:spAutoFit/>
-          </a:bodyPr>
-          <a:lstStyle/>
-          <a:p>
-            <a:pPr algn="l">
-              <a:lnSpc>
-                <a:spcPct val="103000"/>
-              </a:lnSpc>
-            </a:pPr>
-            <a:r>
-              <a:rPr sz="4200" b="1" spc="-150">
-                <a:solidFill>
-                  <a:srgbClr val="18171F"/>
+            <a:pPr algn="l"/>
+            <a:r>
+              <a:rPr sz="8000" b="1" i="0">
+                <a:solidFill>
+                  <a:srgbClr val="E2CACE"/>
                 </a:solidFill>
                 <a:latin typeface="Space Grotesk"/>
               </a:rPr>
-              <a:t>Give it your context, once</a:t>
-            </a:r>
-          </a:p>
-        </p:txBody>
-      </p:sp>
-      <p:sp>
-        <p:nvSpPr>
-          <p:cNvPr id="5" name="TextBox 4"/>
-          <p:cNvSpPr txBox="1"/>
-          <p:nvPr/>
-        </p:nvSpPr>
-        <p:spPr>
-          <a:xfrm>
-            <a:off x="822960" y="2651760"/>
-            <a:ext cx="10424160" cy="2743200"/>
-          </a:xfrm>
-          <a:prstGeom prst="rect">
-            <a:avLst/>
-          </a:prstGeom>
-          <a:noFill/>
-        </p:spPr>
-        <p:txBody>
-          <a:bodyPr wrap="square">
-            <a:spAutoFit/>
-          </a:bodyPr>
-          <a:lstStyle/>
-          <a:p>
-            <a:pPr algn="l">
-              <a:lnSpc>
-                <a:spcPct val="130000"/>
-              </a:lnSpc>
-            </a:pPr>
-            <a:r>
-              <a:rPr sz="2700" b="0">
-                <a:solidFill>
-                  <a:srgbClr val="18171F"/>
-                </a:solidFill>
-                <a:latin typeface="Outfit"/>
-              </a:rPr>
-              <a:t>Set up who you are, your research, your record, your institution, one time. From then on every answer is grounded in you, not in a stranger's guess.</a:t>
-            </a:r>
-          </a:p>
-        </p:txBody>
-      </p:sp>
-    </p:spTree>
-  </p:cSld>
-  <p:clrMapOvr>
-    <a:masterClrMapping/>
-  </p:clrMapOvr>
-</p:sld>
-</file>
-
-<file path=ppt/slides/slide4.xml><?xml version="1.0" encoding="utf-8"?>
-<p:sld xmlns:a="http://schemas.openxmlformats.org/drawingml/2006/main" xmlns:p="http://schemas.openxmlformats.org/presentationml/2006/main" xmlns:r="http://schemas.openxmlformats.org/officeDocument/2006/relationships">
-  <p:cSld>
-    <p:spTree>
-      <p:nvGrpSpPr>
-        <p:cNvPr id="1" name=""/>
-        <p:cNvGrpSpPr/>
-        <p:nvPr/>
-      </p:nvGrpSpPr>
-      <p:grpSpPr/>
-      <p:sp>
-        <p:nvSpPr>
-          <p:cNvPr id="2" name="Rectangle 1"/>
+              <a:t>02</a:t>
+            </a:r>
+          </a:p>
+        </p:txBody>
+      </p:sp>
+      <p:sp>
+        <p:nvSpPr>
+          <p:cNvPr id="11" name="Rectangle 10"/>
           <p:cNvSpPr/>
           <p:nvPr/>
         </p:nvSpPr>
         <p:spPr>
-          <a:xfrm>
-            <a:off x="0" y="0"/>
-            <a:ext cx="12191695" cy="6858000"/>
+          <a:xfrm rot="90000">
+            <a:off x="4724247" y="4297680"/>
+            <a:ext cx="960120" cy="292608"/>
           </a:xfrm>
           <a:prstGeom prst="rect">
             <a:avLst/>
           </a:prstGeom>
           <a:solidFill>
-            <a:srgbClr val="18171F"/>
+            <a:srgbClr val="9E3E58"/>
           </a:solidFill>
           <a:ln>
             <a:noFill/>
           </a:ln>
-          <a:effectLst/>
         </p:spPr>
         <p:style>
           <a:lnRef idx="1">
@@ -4354,34 +4178,114 @@
           </a:fontRef>
         </p:style>
         <p:txBody>
-          <a:bodyPr rtlCol="0" anchor="ctr"/>
+          <a:bodyPr rtlCol="0" anchor="ctr" lIns="54864" rIns="54864" tIns="18288" bIns="18288"/>
           <a:lstStyle/>
           <a:p>
             <a:pPr algn="ctr"/>
-          </a:p>
-        </p:txBody>
-      </p:sp>
-      <p:sp>
-        <p:nvSpPr>
-          <p:cNvPr id="3" name="Rectangle 2"/>
+            <a:r>
+              <a:rPr sz="800" b="1" spc="300">
+                <a:solidFill>
+                  <a:srgbClr val="E5E6E0"/>
+                </a:solidFill>
+                <a:latin typeface="Space Grotesk"/>
+              </a:rPr>
+              <a:t>TERM</a:t>
+            </a:r>
+          </a:p>
+        </p:txBody>
+      </p:sp>
+      <p:sp>
+        <p:nvSpPr>
+          <p:cNvPr id="12" name="TextBox 11"/>
+          <p:cNvSpPr txBox="1"/>
+          <p:nvPr/>
+        </p:nvSpPr>
+        <p:spPr>
+          <a:xfrm rot="90000">
+            <a:off x="4724247" y="4709160"/>
+            <a:ext cx="2743200" cy="548640"/>
+          </a:xfrm>
+          <a:prstGeom prst="rect">
+            <a:avLst/>
+          </a:prstGeom>
+          <a:noFill/>
+        </p:spPr>
+        <p:txBody>
+          <a:bodyPr wrap="square" lIns="0" rIns="0" tIns="0" bIns="0">
+            <a:spAutoFit/>
+          </a:bodyPr>
+          <a:lstStyle/>
+          <a:p>
+            <a:pPr algn="l"/>
+            <a:r>
+              <a:rPr sz="2200" b="1" i="0">
+                <a:solidFill>
+                  <a:srgbClr val="18171F"/>
+                </a:solidFill>
+                <a:latin typeface="Space Grotesk"/>
+              </a:rPr>
+              <a:t>Chatbot vs Agent</a:t>
+            </a:r>
+          </a:p>
+        </p:txBody>
+      </p:sp>
+      <p:sp>
+        <p:nvSpPr>
+          <p:cNvPr id="13" name="TextBox 12"/>
+          <p:cNvSpPr txBox="1"/>
+          <p:nvPr/>
+        </p:nvSpPr>
+        <p:spPr>
+          <a:xfrm rot="90000">
+            <a:off x="4724247" y="5257800"/>
+            <a:ext cx="2743200" cy="914400"/>
+          </a:xfrm>
+          <a:prstGeom prst="rect">
+            <a:avLst/>
+          </a:prstGeom>
+          <a:noFill/>
+        </p:spPr>
+        <p:txBody>
+          <a:bodyPr wrap="square" lIns="0" rIns="0" tIns="0" bIns="0">
+            <a:spAutoFit/>
+          </a:bodyPr>
+          <a:lstStyle/>
+          <a:p>
+            <a:pPr algn="l"/>
+            <a:r>
+              <a:rPr sz="1300" b="0" i="0">
+                <a:solidFill>
+                  <a:srgbClr val="3D3B47"/>
+                </a:solidFill>
+                <a:latin typeface="Outfit"/>
+              </a:rPr>
+              <a:t>A chatbot replies. An agent takes steps and uses tools for you.</a:t>
+            </a:r>
+          </a:p>
+        </p:txBody>
+      </p:sp>
+      <p:sp>
+        <p:nvSpPr>
+          <p:cNvPr id="14" name="Rectangle 13"/>
           <p:cNvSpPr/>
           <p:nvPr/>
         </p:nvSpPr>
         <p:spPr>
-          <a:xfrm>
-            <a:off x="822960" y="1371600"/>
-            <a:ext cx="1371600" cy="82296"/>
+          <a:xfrm rot="21540000">
+            <a:off x="8107527" y="2926080"/>
+            <a:ext cx="3383280" cy="3291840"/>
           </a:xfrm>
           <a:prstGeom prst="rect">
             <a:avLst/>
           </a:prstGeom>
           <a:solidFill>
-            <a:srgbClr val="B30022"/>
+            <a:srgbClr val="FFFFFF"/>
           </a:solidFill>
-          <a:ln>
-            <a:noFill/>
+          <a:ln w="6350">
+            <a:solidFill>
+              <a:srgbClr val="E0DAD2"/>
+            </a:solidFill>
           </a:ln>
-          <a:effectLst/>
         </p:spPr>
         <p:style>
           <a:lnRef idx="1">
@@ -4407,14 +4311,14 @@
       </p:sp>
       <p:sp>
         <p:nvSpPr>
-          <p:cNvPr id="4" name="TextBox 3"/>
+          <p:cNvPr id="15" name="TextBox 14"/>
           <p:cNvSpPr txBox="1"/>
           <p:nvPr/>
         </p:nvSpPr>
         <p:spPr>
-          <a:xfrm>
-            <a:off x="822960" y="1600200"/>
-            <a:ext cx="10607040" cy="1280160"/>
+          <a:xfrm rot="21540000">
+            <a:off x="8427567" y="3063240"/>
+            <a:ext cx="2011680" cy="1463040"/>
           </a:xfrm>
           <a:prstGeom prst="rect">
             <a:avLst/>
@@ -4422,174 +4326,44 @@
           <a:noFill/>
         </p:spPr>
         <p:txBody>
-          <a:bodyPr wrap="square">
+          <a:bodyPr wrap="square" lIns="0" rIns="0" tIns="0" bIns="0">
             <a:spAutoFit/>
           </a:bodyPr>
           <a:lstStyle/>
           <a:p>
-            <a:pPr algn="l">
-              <a:lnSpc>
-                <a:spcPct val="103000"/>
-              </a:lnSpc>
-            </a:pPr>
-            <a:r>
-              <a:rPr sz="4400" b="1" spc="-150">
-                <a:solidFill>
-                  <a:srgbClr val="E5E6E0"/>
+            <a:pPr algn="l"/>
+            <a:r>
+              <a:rPr sz="8000" b="1" i="0">
+                <a:solidFill>
+                  <a:srgbClr val="E2CACE"/>
                 </a:solidFill>
                 <a:latin typeface="Space Grotesk"/>
               </a:rPr>
-              <a:t>Grounded beats generic</a:t>
-            </a:r>
-          </a:p>
-        </p:txBody>
-      </p:sp>
-      <p:sp>
-        <p:nvSpPr>
-          <p:cNvPr id="5" name="TextBox 4"/>
-          <p:cNvSpPr txBox="1"/>
-          <p:nvPr/>
-        </p:nvSpPr>
-        <p:spPr>
-          <a:xfrm>
-            <a:off x="822960" y="2834640"/>
-            <a:ext cx="10607040" cy="3840480"/>
-          </a:xfrm>
-          <a:prstGeom prst="rect">
-            <a:avLst/>
-          </a:prstGeom>
-          <a:noFill/>
-        </p:spPr>
-        <p:txBody>
-          <a:bodyPr wrap="square">
-            <a:spAutoFit/>
-          </a:bodyPr>
-          <a:lstStyle/>
-          <a:p>
-            <a:pPr>
-              <a:lnSpc>
-                <a:spcPct val="112000"/>
-              </a:lnSpc>
-              <a:spcAft>
-                <a:spcPts val="1600"/>
-              </a:spcAft>
-            </a:pPr>
-            <a:r>
-              <a:rPr sz="2700" b="1" spc="-50">
-                <a:solidFill>
-                  <a:srgbClr val="B30022"/>
-                </a:solidFill>
-                <a:latin typeface="Space Grotesk"/>
-              </a:rPr>
-              <a:t>Better output.</a:t>
-            </a:r>
-            <a:r>
-              <a:rPr sz="2700">
-                <a:solidFill>
-                  <a:srgbClr val="E5E6E0"/>
-                </a:solidFill>
-                <a:latin typeface="Outfit"/>
-              </a:rPr>
-              <a:t>  It uses your real record, not filler.</a:t>
-            </a:r>
-          </a:p>
-          <a:p>
-            <a:pPr>
-              <a:lnSpc>
-                <a:spcPct val="112000"/>
-              </a:lnSpc>
-              <a:spcAft>
-                <a:spcPts val="1600"/>
-              </a:spcAft>
-            </a:pPr>
-            <a:r>
-              <a:rPr sz="2700" b="1" spc="-50">
-                <a:solidFill>
-                  <a:srgbClr val="B30022"/>
-                </a:solidFill>
-                <a:latin typeface="Space Grotesk"/>
-              </a:rPr>
-              <a:t>Less back and forth.</a:t>
-            </a:r>
-            <a:r>
-              <a:rPr sz="2700">
-                <a:solidFill>
-                  <a:srgbClr val="E5E6E0"/>
-                </a:solidFill>
-                <a:latin typeface="Outfit"/>
-              </a:rPr>
-              <a:t>  Fewer corrections, fewer re-explanations.</a:t>
-            </a:r>
-          </a:p>
-          <a:p>
-            <a:pPr>
-              <a:lnSpc>
-                <a:spcPct val="112000"/>
-              </a:lnSpc>
-              <a:spcAft>
-                <a:spcPts val="1600"/>
-              </a:spcAft>
-            </a:pPr>
-            <a:r>
-              <a:rPr sz="2700" b="1" spc="-50">
-                <a:solidFill>
-                  <a:srgbClr val="B30022"/>
-                </a:solidFill>
-                <a:latin typeface="Space Grotesk"/>
-              </a:rPr>
-              <a:t>Lower cost.</a:t>
-            </a:r>
-            <a:r>
-              <a:rPr sz="2700">
-                <a:solidFill>
-                  <a:srgbClr val="E5E6E0"/>
-                </a:solidFill>
-                <a:latin typeface="Outfit"/>
-              </a:rPr>
-              <a:t>  Fewer wasted tokens means less money spent.</a:t>
-            </a:r>
-          </a:p>
-        </p:txBody>
-      </p:sp>
-    </p:spTree>
-  </p:cSld>
-  <p:clrMapOvr>
-    <a:masterClrMapping/>
-  </p:clrMapOvr>
-</p:sld>
-</file>
-
-<file path=ppt/slides/slide5.xml><?xml version="1.0" encoding="utf-8"?>
-<p:sld xmlns:a="http://schemas.openxmlformats.org/drawingml/2006/main" xmlns:p="http://schemas.openxmlformats.org/presentationml/2006/main" xmlns:r="http://schemas.openxmlformats.org/officeDocument/2006/relationships">
-  <p:cSld>
-    <p:spTree>
-      <p:nvGrpSpPr>
-        <p:cNvPr id="1" name=""/>
-        <p:cNvGrpSpPr/>
-        <p:nvPr/>
-      </p:nvGrpSpPr>
-      <p:grpSpPr/>
-      <p:sp>
-        <p:nvSpPr>
-          <p:cNvPr id="2" name="Rectangle 1"/>
+              <a:t>03</a:t>
+            </a:r>
+          </a:p>
+        </p:txBody>
+      </p:sp>
+      <p:sp>
+        <p:nvSpPr>
+          <p:cNvPr id="16" name="Rectangle 15"/>
           <p:cNvSpPr/>
           <p:nvPr/>
         </p:nvSpPr>
         <p:spPr>
-          <a:xfrm>
-            <a:off x="0" y="0"/>
-            <a:ext cx="12191695" cy="6858000"/>
+          <a:xfrm rot="21540000">
+            <a:off x="8427567" y="4297680"/>
+            <a:ext cx="960120" cy="292608"/>
           </a:xfrm>
           <a:prstGeom prst="rect">
             <a:avLst/>
           </a:prstGeom>
           <a:solidFill>
-            <a:srgbClr val="E5E6E0"/>
+            <a:srgbClr val="9E3E58"/>
           </a:solidFill>
           <a:ln>
             <a:noFill/>
           </a:ln>
-          <a:effectLst/>
         </p:spPr>
         <p:style>
           <a:lnRef idx="1">
@@ -4606,10 +4380,150 @@
           </a:fontRef>
         </p:style>
         <p:txBody>
-          <a:bodyPr rtlCol="0" anchor="ctr"/>
+          <a:bodyPr rtlCol="0" anchor="ctr" lIns="54864" rIns="54864" tIns="18288" bIns="18288"/>
           <a:lstStyle/>
           <a:p>
             <a:pPr algn="ctr"/>
+            <a:r>
+              <a:rPr sz="800" b="1" spc="300">
+                <a:solidFill>
+                  <a:srgbClr val="E5E6E0"/>
+                </a:solidFill>
+                <a:latin typeface="Space Grotesk"/>
+              </a:rPr>
+              <a:t>TERM</a:t>
+            </a:r>
+          </a:p>
+        </p:txBody>
+      </p:sp>
+      <p:sp>
+        <p:nvSpPr>
+          <p:cNvPr id="17" name="TextBox 16"/>
+          <p:cNvSpPr txBox="1"/>
+          <p:nvPr/>
+        </p:nvSpPr>
+        <p:spPr>
+          <a:xfrm rot="21540000">
+            <a:off x="8427567" y="4709160"/>
+            <a:ext cx="2743200" cy="548640"/>
+          </a:xfrm>
+          <a:prstGeom prst="rect">
+            <a:avLst/>
+          </a:prstGeom>
+          <a:noFill/>
+        </p:spPr>
+        <p:txBody>
+          <a:bodyPr wrap="square" lIns="0" rIns="0" tIns="0" bIns="0">
+            <a:spAutoFit/>
+          </a:bodyPr>
+          <a:lstStyle/>
+          <a:p>
+            <a:pPr algn="l"/>
+            <a:r>
+              <a:rPr sz="2200" b="1" i="0">
+                <a:solidFill>
+                  <a:srgbClr val="18171F"/>
+                </a:solidFill>
+                <a:latin typeface="Space Grotesk"/>
+              </a:rPr>
+              <a:t>The Workspace</a:t>
+            </a:r>
+          </a:p>
+        </p:txBody>
+      </p:sp>
+      <p:sp>
+        <p:nvSpPr>
+          <p:cNvPr id="18" name="TextBox 17"/>
+          <p:cNvSpPr txBox="1"/>
+          <p:nvPr/>
+        </p:nvSpPr>
+        <p:spPr>
+          <a:xfrm rot="21540000">
+            <a:off x="8427567" y="5257800"/>
+            <a:ext cx="2743200" cy="914400"/>
+          </a:xfrm>
+          <a:prstGeom prst="rect">
+            <a:avLst/>
+          </a:prstGeom>
+          <a:noFill/>
+        </p:spPr>
+        <p:txBody>
+          <a:bodyPr wrap="square" lIns="0" rIns="0" tIns="0" bIns="0">
+            <a:spAutoFit/>
+          </a:bodyPr>
+          <a:lstStyle/>
+          <a:p>
+            <a:pPr algn="l"/>
+            <a:r>
+              <a:rPr sz="1300" b="0" i="0">
+                <a:solidFill>
+                  <a:srgbClr val="3D3B47"/>
+                </a:solidFill>
+                <a:latin typeface="Outfit"/>
+              </a:rPr>
+              <a:t>A prompt is what you ask. A workspace is your context and skills, saved and reused.</a:t>
+            </a:r>
+          </a:p>
+        </p:txBody>
+      </p:sp>
+    </p:spTree>
+  </p:cSld>
+  <p:clrMapOvr>
+    <a:masterClrMapping/>
+  </p:clrMapOvr>
+</p:sld>
+</file>
+
+<file path=ppt/slides/slide5.xml><?xml version="1.0" encoding="utf-8"?>
+<p:sld xmlns:a="http://schemas.openxmlformats.org/drawingml/2006/main" xmlns:p="http://schemas.openxmlformats.org/presentationml/2006/main" xmlns:r="http://schemas.openxmlformats.org/officeDocument/2006/relationships">
+  <p:cSld>
+    <p:bg>
+      <p:bgPr>
+        <a:solidFill>
+          <a:srgbClr val="E5E6E0"/>
+        </a:solidFill>
+        <a:effectLst/>
+      </p:bgPr>
+    </p:bg>
+    <p:spTree>
+      <p:nvGrpSpPr>
+        <p:cNvPr id="1" name=""/>
+        <p:cNvGrpSpPr/>
+        <p:nvPr/>
+      </p:nvGrpSpPr>
+      <p:grpSpPr/>
+      <p:sp>
+        <p:nvSpPr>
+          <p:cNvPr id="2" name="TextBox 1"/>
+          <p:cNvSpPr txBox="1"/>
+          <p:nvPr/>
+        </p:nvSpPr>
+        <p:spPr>
+          <a:xfrm>
+            <a:off x="822960" y="1280160"/>
+            <a:ext cx="1828800" cy="2286000"/>
+          </a:xfrm>
+          <a:prstGeom prst="rect">
+            <a:avLst/>
+          </a:prstGeom>
+          <a:noFill/>
+        </p:spPr>
+        <p:txBody>
+          <a:bodyPr wrap="square" lIns="0" rIns="0" tIns="0" bIns="0">
+            <a:spAutoFit/>
+          </a:bodyPr>
+          <a:lstStyle/>
+          <a:p>
+            <a:pPr algn="l"/>
+            <a:r>
+              <a:rPr sz="20000" b="1" i="0">
+                <a:solidFill>
+                  <a:srgbClr val="B30022"/>
+                </a:solidFill>
+                <a:latin typeface="Caveat"/>
+              </a:rPr>
+              <a:t>“</a:t>
+            </a:r>
           </a:p>
         </p:txBody>
       </p:sp>
@@ -4621,8 +4535,8 @@
         </p:nvSpPr>
         <p:spPr>
           <a:xfrm>
-            <a:off x="822960" y="658368"/>
-            <a:ext cx="9144000" cy="640080"/>
+            <a:off x="2377440" y="1645920"/>
+            <a:ext cx="9418320" cy="3840480"/>
           </a:xfrm>
           <a:prstGeom prst="rect">
             <a:avLst/>
@@ -4630,24 +4544,30 @@
           <a:noFill/>
         </p:spPr>
         <p:txBody>
-          <a:bodyPr wrap="square">
+          <a:bodyPr wrap="square" lIns="0" rIns="0" tIns="0" bIns="0">
             <a:spAutoFit/>
           </a:bodyPr>
           <a:lstStyle/>
           <a:p>
-            <a:pPr algn="l">
-              <a:lnSpc>
-                <a:spcPct val="110000"/>
-              </a:lnSpc>
-            </a:pPr>
-            <a:r>
-              <a:rPr sz="3200" b="1">
+            <a:pPr algn="l"/>
+            <a:r>
+              <a:rPr sz="5200" b="1" i="0">
                 <a:solidFill>
                   <a:srgbClr val="9E3E58"/>
                 </a:solidFill>
                 <a:latin typeface="Caveat"/>
               </a:rPr>
-              <a:t>same page</a:t>
+              <a:t>The fix was not a smarter prompt.</a:t>
+            </a:r>
+          </a:p>
+          <a:p>
+            <a:r>
+              <a:t>It was context</a:t>
+            </a:r>
+          </a:p>
+          <a:p>
+            <a:r>
+              <a:t>the AI already had.</a:t>
             </a:r>
           </a:p>
         </p:txBody>
@@ -4660,8 +4580,8 @@
         </p:nvSpPr>
         <p:spPr>
           <a:xfrm>
-            <a:off x="822960" y="1234440"/>
-            <a:ext cx="10607040" cy="1280160"/>
+            <a:off x="2377440" y="5852160"/>
+            <a:ext cx="9144000" cy="457200"/>
           </a:xfrm>
           <a:prstGeom prst="rect">
             <a:avLst/>
@@ -4669,131 +4589,20 @@
           <a:noFill/>
         </p:spPr>
         <p:txBody>
-          <a:bodyPr wrap="square">
+          <a:bodyPr wrap="square" lIns="0" rIns="0" tIns="0" bIns="0">
             <a:spAutoFit/>
           </a:bodyPr>
           <a:lstStyle/>
           <a:p>
-            <a:pPr algn="l">
-              <a:lnSpc>
-                <a:spcPct val="103000"/>
-              </a:lnSpc>
-            </a:pPr>
-            <a:r>
-              <a:rPr sz="4000" b="1" spc="-150">
+            <a:pPr algn="l"/>
+            <a:r>
+              <a:rPr sz="1200" b="1" i="0" spc="400">
                 <a:solidFill>
                   <a:srgbClr val="18171F"/>
                 </a:solidFill>
                 <a:latin typeface="Space Grotesk"/>
               </a:rPr>
-              <a:t>The words we will use</a:t>
-            </a:r>
-          </a:p>
-        </p:txBody>
-      </p:sp>
-      <p:sp>
-        <p:nvSpPr>
-          <p:cNvPr id="5" name="TextBox 4"/>
-          <p:cNvSpPr txBox="1"/>
-          <p:nvPr/>
-        </p:nvSpPr>
-        <p:spPr>
-          <a:xfrm>
-            <a:off x="822960" y="2651760"/>
-            <a:ext cx="10607040" cy="3840480"/>
-          </a:xfrm>
-          <a:prstGeom prst="rect">
-            <a:avLst/>
-          </a:prstGeom>
-          <a:noFill/>
-        </p:spPr>
-        <p:txBody>
-          <a:bodyPr wrap="square">
-            <a:spAutoFit/>
-          </a:bodyPr>
-          <a:lstStyle/>
-          <a:p>
-            <a:pPr>
-              <a:lnSpc>
-                <a:spcPct val="112000"/>
-              </a:lnSpc>
-              <a:spcAft>
-                <a:spcPts val="1600"/>
-              </a:spcAft>
-            </a:pPr>
-            <a:r>
-              <a:rPr sz="2500" b="1" spc="-50">
-                <a:solidFill>
-                  <a:srgbClr val="B30022"/>
-                </a:solidFill>
-                <a:latin typeface="Space Grotesk"/>
-              </a:rPr>
-              <a:t>AI vs LLM.</a:t>
-            </a:r>
-            <a:r>
-              <a:rPr sz="2500">
-                <a:solidFill>
-                  <a:srgbClr val="18171F"/>
-                </a:solidFill>
-                <a:latin typeface="Outfit"/>
-              </a:rPr>
-              <a:t>  AI is the field; an LLM is the text-trained model we use.</a:t>
-            </a:r>
-          </a:p>
-          <a:p>
-            <a:pPr>
-              <a:lnSpc>
-                <a:spcPct val="112000"/>
-              </a:lnSpc>
-              <a:spcAft>
-                <a:spcPts val="1600"/>
-              </a:spcAft>
-            </a:pPr>
-            <a:r>
-              <a:rPr sz="2500" b="1" spc="-50">
-                <a:solidFill>
-                  <a:srgbClr val="B30022"/>
-                </a:solidFill>
-                <a:latin typeface="Space Grotesk"/>
-              </a:rPr>
-              <a:t>Chatbot vs agent.</a:t>
-            </a:r>
-            <a:r>
-              <a:rPr sz="2500">
-                <a:solidFill>
-                  <a:srgbClr val="18171F"/>
-                </a:solidFill>
-                <a:latin typeface="Outfit"/>
-              </a:rPr>
-              <a:t>  A chatbot replies; an agent takes steps and uses tools.</a:t>
-            </a:r>
-          </a:p>
-          <a:p>
-            <a:pPr>
-              <a:lnSpc>
-                <a:spcPct val="112000"/>
-              </a:lnSpc>
-              <a:spcAft>
-                <a:spcPts val="1600"/>
-              </a:spcAft>
-            </a:pPr>
-            <a:r>
-              <a:rPr sz="2500" b="1" spc="-50">
-                <a:solidFill>
-                  <a:srgbClr val="B30022"/>
-                </a:solidFill>
-                <a:latin typeface="Space Grotesk"/>
-              </a:rPr>
-              <a:t>Prompt, skill, workspace.</a:t>
-            </a:r>
-            <a:r>
-              <a:rPr sz="2500">
-                <a:solidFill>
-                  <a:srgbClr val="18171F"/>
-                </a:solidFill>
-                <a:latin typeface="Outfit"/>
-              </a:rPr>
-              <a:t>  What you ask, a saved instruction, and your context plus skills in one place.</a:t>
+              <a:t>— ASHLEY SCRUSE</a:t>
             </a:r>
           </a:p>
         </p:txBody>
@@ -4809,6 +4618,14 @@
 <file path=ppt/slides/slide6.xml><?xml version="1.0" encoding="utf-8"?>
 <p:sld xmlns:a="http://schemas.openxmlformats.org/drawingml/2006/main" xmlns:p="http://schemas.openxmlformats.org/presentationml/2006/main" xmlns:r="http://schemas.openxmlformats.org/officeDocument/2006/relationships">
   <p:cSld>
+    <p:bg>
+      <p:bgPr>
+        <a:solidFill>
+          <a:srgbClr val="E5E6E0"/>
+        </a:solidFill>
+        <a:effectLst/>
+      </p:bgPr>
+    </p:bg>
     <p:spTree>
       <p:nvGrpSpPr>
         <p:cNvPr id="1" name=""/>
@@ -4823,20 +4640,19 @@
           <p:nvPr/>
         </p:nvSpPr>
         <p:spPr>
-          <a:xfrm>
-            <a:off x="0" y="0"/>
-            <a:ext cx="12191695" cy="6858000"/>
-          </a:xfrm>
-          <a:prstGeom prst="rect">
-            <a:avLst/>
-          </a:prstGeom>
-          <a:solidFill>
-            <a:srgbClr val="E5E6E0"/>
-          </a:solidFill>
-          <a:ln>
-            <a:noFill/>
+          <a:xfrm rot="21480000">
+            <a:off x="822960" y="914400"/>
+            <a:ext cx="2194560" cy="384048"/>
+          </a:xfrm>
+          <a:prstGeom prst="rect">
+            <a:avLst/>
+          </a:prstGeom>
+          <a:noFill/>
+          <a:ln w="19050">
+            <a:solidFill>
+              <a:srgbClr val="9E3E58"/>
+            </a:solidFill>
           </a:ln>
-          <a:effectLst/>
         </p:spPr>
         <p:style>
           <a:lnRef idx="1">
@@ -4853,10 +4669,19 @@
           </a:fontRef>
         </p:style>
         <p:txBody>
-          <a:bodyPr rtlCol="0" anchor="ctr"/>
+          <a:bodyPr rtlCol="0" anchor="ctr" lIns="109728" rIns="109728" tIns="36576" bIns="36576"/>
           <a:lstStyle/>
           <a:p>
             <a:pPr algn="ctr"/>
+            <a:r>
+              <a:rPr sz="1000" b="1" spc="200">
+                <a:solidFill>
+                  <a:srgbClr val="9E3E58"/>
+                </a:solidFill>
+                <a:latin typeface="Space Grotesk"/>
+              </a:rPr>
+              <a:t>THE PAYOFF</a:t>
+            </a:r>
           </a:p>
         </p:txBody>
       </p:sp>
@@ -4868,8 +4693,8 @@
         </p:nvSpPr>
         <p:spPr>
           <a:xfrm>
-            <a:off x="822960" y="658368"/>
-            <a:ext cx="9144000" cy="640080"/>
+            <a:off x="822960" y="1554480"/>
+            <a:ext cx="5943600" cy="822960"/>
           </a:xfrm>
           <a:prstGeom prst="rect">
             <a:avLst/>
@@ -4877,24 +4702,20 @@
           <a:noFill/>
         </p:spPr>
         <p:txBody>
-          <a:bodyPr wrap="square">
+          <a:bodyPr wrap="square" lIns="0" rIns="0" tIns="0" bIns="0">
             <a:spAutoFit/>
           </a:bodyPr>
           <a:lstStyle/>
           <a:p>
-            <a:pPr algn="l">
-              <a:lnSpc>
-                <a:spcPct val="110000"/>
-              </a:lnSpc>
-            </a:pPr>
-            <a:r>
-              <a:rPr sz="3200" b="1">
+            <a:pPr algn="l"/>
+            <a:r>
+              <a:rPr sz="3800" b="1" i="0">
                 <a:solidFill>
                   <a:srgbClr val="9E3E58"/>
                 </a:solidFill>
                 <a:latin typeface="Caveat"/>
               </a:rPr>
-              <a:t>same page</a:t>
+              <a:t>Fill it once.</a:t>
             </a:r>
           </a:p>
         </p:txBody>
@@ -4907,8 +4728,8 @@
         </p:nvSpPr>
         <p:spPr>
           <a:xfrm>
-            <a:off x="822960" y="1234440"/>
-            <a:ext cx="10607040" cy="1280160"/>
+            <a:off x="822960" y="2286000"/>
+            <a:ext cx="5943600" cy="1097280"/>
           </a:xfrm>
           <a:prstGeom prst="rect">
             <a:avLst/>
@@ -4916,24 +4737,20 @@
           <a:noFill/>
         </p:spPr>
         <p:txBody>
-          <a:bodyPr wrap="square">
+          <a:bodyPr wrap="square" lIns="0" rIns="0" tIns="0" bIns="0">
             <a:spAutoFit/>
           </a:bodyPr>
           <a:lstStyle/>
           <a:p>
-            <a:pPr algn="l">
-              <a:lnSpc>
-                <a:spcPct val="103000"/>
-              </a:lnSpc>
-            </a:pPr>
-            <a:r>
-              <a:rPr sz="3800" b="1" spc="-150">
+            <a:pPr algn="l"/>
+            <a:r>
+              <a:rPr sz="5400" b="1" i="0" spc="-150">
                 <a:solidFill>
                   <a:srgbClr val="18171F"/>
                 </a:solidFill>
                 <a:latin typeface="Space Grotesk"/>
               </a:rPr>
-              <a:t>Tokens and the context window</a:t>
+              <a:t>EVERY GRANT.</a:t>
             </a:r>
           </a:p>
         </p:txBody>
@@ -4946,8 +4763,8 @@
         </p:nvSpPr>
         <p:spPr>
           <a:xfrm>
-            <a:off x="822960" y="2651760"/>
-            <a:ext cx="10607040" cy="3840480"/>
+            <a:off x="822960" y="3566160"/>
+            <a:ext cx="5943600" cy="2286000"/>
           </a:xfrm>
           <a:prstGeom prst="rect">
             <a:avLst/>
@@ -4955,92 +4772,55 @@
           <a:noFill/>
         </p:spPr>
         <p:txBody>
-          <a:bodyPr wrap="square">
+          <a:bodyPr wrap="square" lIns="0" rIns="0" tIns="0" bIns="0">
             <a:spAutoFit/>
           </a:bodyPr>
           <a:lstStyle/>
           <a:p>
-            <a:pPr>
-              <a:lnSpc>
-                <a:spcPct val="112000"/>
-              </a:lnSpc>
-              <a:spcAft>
-                <a:spcPts val="1600"/>
-              </a:spcAft>
-            </a:pPr>
-            <a:r>
-              <a:rPr sz="2500" b="1" spc="-50">
+            <a:pPr algn="l"/>
+            <a:r>
+              <a:rPr sz="1700" b="0" i="0">
+                <a:solidFill>
+                  <a:srgbClr val="3D3B47"/>
+                </a:solidFill>
+                <a:latin typeface="Outfit"/>
+              </a:rPr>
+              <a:t>You set up your context one time. From then on every evaluation and every draft reads from it, so you never start from zero again.</a:t>
+            </a:r>
+          </a:p>
+        </p:txBody>
+      </p:sp>
+      <p:sp>
+        <p:nvSpPr>
+          <p:cNvPr id="6" name="TextBox 5"/>
+          <p:cNvSpPr txBox="1"/>
+          <p:nvPr/>
+        </p:nvSpPr>
+        <p:spPr>
+          <a:xfrm>
+            <a:off x="7132320" y="822960"/>
+            <a:ext cx="4937760" cy="5669280"/>
+          </a:xfrm>
+          <a:prstGeom prst="rect">
+            <a:avLst/>
+          </a:prstGeom>
+          <a:noFill/>
+        </p:spPr>
+        <p:txBody>
+          <a:bodyPr wrap="none" lIns="0" rIns="0" tIns="0" bIns="0">
+            <a:spAutoFit/>
+          </a:bodyPr>
+          <a:lstStyle/>
+          <a:p>
+            <a:pPr algn="ctr"/>
+            <a:r>
+              <a:rPr sz="28000" b="1" i="0" spc="-200">
                 <a:solidFill>
                   <a:srgbClr val="B30022"/>
                 </a:solidFill>
                 <a:latin typeface="Space Grotesk"/>
               </a:rPr>
-              <a:t>Tokens.</a:t>
-            </a:r>
-            <a:r>
-              <a:rPr sz="2500">
-                <a:solidFill>
-                  <a:srgbClr val="18171F"/>
-                </a:solidFill>
-                <a:latin typeface="Outfit"/>
-              </a:rPr>
-              <a:t>  The pieces of text the model reads and writes. You pay per token.</a:t>
-            </a:r>
-          </a:p>
-          <a:p>
-            <a:pPr>
-              <a:lnSpc>
-                <a:spcPct val="112000"/>
-              </a:lnSpc>
-              <a:spcAft>
-                <a:spcPts val="1600"/>
-              </a:spcAft>
-            </a:pPr>
-            <a:r>
-              <a:rPr sz="2500" b="1" spc="-50">
-                <a:solidFill>
-                  <a:srgbClr val="B30022"/>
-                </a:solidFill>
-                <a:latin typeface="Space Grotesk"/>
-              </a:rPr>
-              <a:t>Context window.</a:t>
-            </a:r>
-            <a:r>
-              <a:rPr sz="2500">
-                <a:solidFill>
-                  <a:srgbClr val="18171F"/>
-                </a:solidFill>
-                <a:latin typeface="Outfit"/>
-              </a:rPr>
-              <a:t>  How much it can hold in mind at once.</a:t>
-            </a:r>
-          </a:p>
-          <a:p>
-            <a:pPr>
-              <a:lnSpc>
-                <a:spcPct val="112000"/>
-              </a:lnSpc>
-              <a:spcAft>
-                <a:spcPts val="1600"/>
-              </a:spcAft>
-            </a:pPr>
-            <a:r>
-              <a:rPr sz="2500" b="1" spc="-50">
-                <a:solidFill>
-                  <a:srgbClr val="B30022"/>
-                </a:solidFill>
-                <a:latin typeface="Space Grotesk"/>
-              </a:rPr>
-              <a:t>The payoff.</a:t>
-            </a:r>
-            <a:r>
-              <a:rPr sz="2500">
-                <a:solidFill>
-                  <a:srgbClr val="18171F"/>
-                </a:solidFill>
-                <a:latin typeface="Outfit"/>
-              </a:rPr>
-              <a:t>  Good context means you say things once, not every time. That saves tokens, and money.</a:t>
+              <a:t>1</a:t>
             </a:r>
           </a:p>
         </p:txBody>
@@ -5056,6 +4836,14 @@
 <file path=ppt/slides/slide7.xml><?xml version="1.0" encoding="utf-8"?>
 <p:sld xmlns:a="http://schemas.openxmlformats.org/drawingml/2006/main" xmlns:p="http://schemas.openxmlformats.org/presentationml/2006/main" xmlns:r="http://schemas.openxmlformats.org/officeDocument/2006/relationships">
   <p:cSld>
+    <p:bg>
+      <p:bgPr>
+        <a:solidFill>
+          <a:srgbClr val="EDE7DF"/>
+        </a:solidFill>
+        <a:effectLst/>
+      </p:bgPr>
+    </p:bg>
     <p:spTree>
       <p:nvGrpSpPr>
         <p:cNvPr id="1" name=""/>
@@ -5065,25 +4853,444 @@
       <p:grpSpPr/>
       <p:sp>
         <p:nvSpPr>
-          <p:cNvPr id="2" name="Rectangle 1"/>
+          <p:cNvPr id="2" name="TextBox 1"/>
+          <p:cNvSpPr txBox="1"/>
+          <p:nvPr/>
+        </p:nvSpPr>
+        <p:spPr>
+          <a:xfrm>
+            <a:off x="822960" y="640080"/>
+            <a:ext cx="9144000" cy="731520"/>
+          </a:xfrm>
+          <a:prstGeom prst="rect">
+            <a:avLst/>
+          </a:prstGeom>
+          <a:noFill/>
+        </p:spPr>
+        <p:txBody>
+          <a:bodyPr wrap="square" lIns="0" rIns="0" tIns="0" bIns="0">
+            <a:spAutoFit/>
+          </a:bodyPr>
+          <a:lstStyle/>
+          <a:p>
+            <a:pPr algn="l"/>
+            <a:r>
+              <a:rPr sz="3400" b="1" i="0">
+                <a:solidFill>
+                  <a:srgbClr val="9E3E58"/>
+                </a:solidFill>
+                <a:latin typeface="Caveat"/>
+              </a:rPr>
+              <a:t>Good habits.</a:t>
+            </a:r>
+          </a:p>
+        </p:txBody>
+      </p:sp>
+      <p:sp>
+        <p:nvSpPr>
+          <p:cNvPr id="3" name="TextBox 2"/>
+          <p:cNvSpPr txBox="1"/>
+          <p:nvPr/>
+        </p:nvSpPr>
+        <p:spPr>
+          <a:xfrm>
+            <a:off x="822960" y="1280160"/>
+            <a:ext cx="10058400" cy="1280160"/>
+          </a:xfrm>
+          <a:prstGeom prst="rect">
+            <a:avLst/>
+          </a:prstGeom>
+          <a:noFill/>
+        </p:spPr>
+        <p:txBody>
+          <a:bodyPr wrap="square" lIns="0" rIns="0" tIns="0" bIns="0">
+            <a:spAutoFit/>
+          </a:bodyPr>
+          <a:lstStyle/>
+          <a:p>
+            <a:pPr algn="l"/>
+            <a:r>
+              <a:rPr sz="5600" b="1" i="0" spc="-150">
+                <a:solidFill>
+                  <a:srgbClr val="18171F"/>
+                </a:solidFill>
+                <a:latin typeface="Space Grotesk"/>
+              </a:rPr>
+              <a:t>DO THIS, NOT THAT.</a:t>
+            </a:r>
+          </a:p>
+        </p:txBody>
+      </p:sp>
+      <p:sp>
+        <p:nvSpPr>
+          <p:cNvPr id="4" name="TextBox 3"/>
+          <p:cNvSpPr txBox="1"/>
+          <p:nvPr/>
+        </p:nvSpPr>
+        <p:spPr>
+          <a:xfrm>
+            <a:off x="822960" y="3108960"/>
+            <a:ext cx="5029200" cy="548640"/>
+          </a:xfrm>
+          <a:prstGeom prst="rect">
+            <a:avLst/>
+          </a:prstGeom>
+          <a:noFill/>
+        </p:spPr>
+        <p:txBody>
+          <a:bodyPr wrap="square" lIns="0" rIns="0" tIns="0" bIns="0">
+            <a:spAutoFit/>
+          </a:bodyPr>
+          <a:lstStyle/>
+          <a:p>
+            <a:pPr algn="l"/>
+            <a:r>
+              <a:rPr sz="2800" b="1" i="0">
+                <a:solidFill>
+                  <a:srgbClr val="9E3E58"/>
+                </a:solidFill>
+                <a:latin typeface="Caveat"/>
+              </a:rPr>
+              <a:t>Do this</a:t>
+            </a:r>
+          </a:p>
+        </p:txBody>
+      </p:sp>
+      <p:sp>
+        <p:nvSpPr>
+          <p:cNvPr id="5" name="TextBox 4"/>
+          <p:cNvSpPr txBox="1"/>
+          <p:nvPr/>
+        </p:nvSpPr>
+        <p:spPr>
+          <a:xfrm>
+            <a:off x="822960" y="3703320"/>
+            <a:ext cx="5029200" cy="457200"/>
+          </a:xfrm>
+          <a:prstGeom prst="rect">
+            <a:avLst/>
+          </a:prstGeom>
+          <a:noFill/>
+        </p:spPr>
+        <p:txBody>
+          <a:bodyPr wrap="square" lIns="0" rIns="0" tIns="0" bIns="0">
+            <a:spAutoFit/>
+          </a:bodyPr>
+          <a:lstStyle/>
+          <a:p>
+            <a:pPr algn="l"/>
+            <a:r>
+              <a:rPr sz="1500" b="0" i="0">
+                <a:solidFill>
+                  <a:srgbClr val="18171F"/>
+                </a:solidFill>
+                <a:latin typeface="Outfit"/>
+              </a:rPr>
+              <a:t>→  Give it your context first.</a:t>
+            </a:r>
+          </a:p>
+        </p:txBody>
+      </p:sp>
+      <p:sp>
+        <p:nvSpPr>
+          <p:cNvPr id="6" name="TextBox 5"/>
+          <p:cNvSpPr txBox="1"/>
+          <p:nvPr/>
+        </p:nvSpPr>
+        <p:spPr>
+          <a:xfrm>
+            <a:off x="822960" y="4206240"/>
+            <a:ext cx="5029200" cy="457200"/>
+          </a:xfrm>
+          <a:prstGeom prst="rect">
+            <a:avLst/>
+          </a:prstGeom>
+          <a:noFill/>
+        </p:spPr>
+        <p:txBody>
+          <a:bodyPr wrap="square" lIns="0" rIns="0" tIns="0" bIns="0">
+            <a:spAutoFit/>
+          </a:bodyPr>
+          <a:lstStyle/>
+          <a:p>
+            <a:pPr algn="l"/>
+            <a:r>
+              <a:rPr sz="1500" b="0" i="0">
+                <a:solidFill>
+                  <a:srgbClr val="18171F"/>
+                </a:solidFill>
+                <a:latin typeface="Outfit"/>
+              </a:rPr>
+              <a:t>→  Be specific about the goal.</a:t>
+            </a:r>
+          </a:p>
+        </p:txBody>
+      </p:sp>
+      <p:sp>
+        <p:nvSpPr>
+          <p:cNvPr id="7" name="TextBox 6"/>
+          <p:cNvSpPr txBox="1"/>
+          <p:nvPr/>
+        </p:nvSpPr>
+        <p:spPr>
+          <a:xfrm>
+            <a:off x="822960" y="4709160"/>
+            <a:ext cx="5029200" cy="457200"/>
+          </a:xfrm>
+          <a:prstGeom prst="rect">
+            <a:avLst/>
+          </a:prstGeom>
+          <a:noFill/>
+        </p:spPr>
+        <p:txBody>
+          <a:bodyPr wrap="square" lIns="0" rIns="0" tIns="0" bIns="0">
+            <a:spAutoFit/>
+          </a:bodyPr>
+          <a:lstStyle/>
+          <a:p>
+            <a:pPr algn="l"/>
+            <a:r>
+              <a:rPr sz="1500" b="0" i="0">
+                <a:solidFill>
+                  <a:srgbClr val="18171F"/>
+                </a:solidFill>
+                <a:latin typeface="Outfit"/>
+              </a:rPr>
+              <a:t>→  Ground every claim in a source.</a:t>
+            </a:r>
+          </a:p>
+        </p:txBody>
+      </p:sp>
+      <p:sp>
+        <p:nvSpPr>
+          <p:cNvPr id="8" name="TextBox 7"/>
+          <p:cNvSpPr txBox="1"/>
+          <p:nvPr/>
+        </p:nvSpPr>
+        <p:spPr>
+          <a:xfrm>
+            <a:off x="822960" y="5212080"/>
+            <a:ext cx="5029200" cy="457200"/>
+          </a:xfrm>
+          <a:prstGeom prst="rect">
+            <a:avLst/>
+          </a:prstGeom>
+          <a:noFill/>
+        </p:spPr>
+        <p:txBody>
+          <a:bodyPr wrap="square" lIns="0" rIns="0" tIns="0" bIns="0">
+            <a:spAutoFit/>
+          </a:bodyPr>
+          <a:lstStyle/>
+          <a:p>
+            <a:pPr algn="l"/>
+            <a:r>
+              <a:rPr sz="1500" b="0" i="0">
+                <a:solidFill>
+                  <a:srgbClr val="18171F"/>
+                </a:solidFill>
+                <a:latin typeface="Outfit"/>
+              </a:rPr>
+              <a:t>→  Verify before it goes out.</a:t>
+            </a:r>
+          </a:p>
+        </p:txBody>
+      </p:sp>
+      <p:sp>
+        <p:nvSpPr>
+          <p:cNvPr id="9" name="TextBox 8"/>
+          <p:cNvSpPr txBox="1"/>
+          <p:nvPr/>
+        </p:nvSpPr>
+        <p:spPr>
+          <a:xfrm>
+            <a:off x="6400800" y="3108960"/>
+            <a:ext cx="5029200" cy="548640"/>
+          </a:xfrm>
+          <a:prstGeom prst="rect">
+            <a:avLst/>
+          </a:prstGeom>
+          <a:noFill/>
+        </p:spPr>
+        <p:txBody>
+          <a:bodyPr wrap="square" lIns="0" rIns="0" tIns="0" bIns="0">
+            <a:spAutoFit/>
+          </a:bodyPr>
+          <a:lstStyle/>
+          <a:p>
+            <a:pPr algn="l"/>
+            <a:r>
+              <a:rPr sz="2800" b="1" i="0">
+                <a:solidFill>
+                  <a:srgbClr val="9E3E58"/>
+                </a:solidFill>
+                <a:latin typeface="Caveat"/>
+              </a:rPr>
+              <a:t>Not this</a:t>
+            </a:r>
+          </a:p>
+        </p:txBody>
+      </p:sp>
+      <p:sp>
+        <p:nvSpPr>
+          <p:cNvPr id="10" name="TextBox 9"/>
+          <p:cNvSpPr txBox="1"/>
+          <p:nvPr/>
+        </p:nvSpPr>
+        <p:spPr>
+          <a:xfrm>
+            <a:off x="6400800" y="3703320"/>
+            <a:ext cx="5029200" cy="457200"/>
+          </a:xfrm>
+          <a:prstGeom prst="rect">
+            <a:avLst/>
+          </a:prstGeom>
+          <a:noFill/>
+        </p:spPr>
+        <p:txBody>
+          <a:bodyPr wrap="square" lIns="0" rIns="0" tIns="0" bIns="0">
+            <a:spAutoFit/>
+          </a:bodyPr>
+          <a:lstStyle/>
+          <a:p>
+            <a:pPr algn="l"/>
+            <a:r>
+              <a:rPr sz="1500" b="0" i="0">
+                <a:solidFill>
+                  <a:srgbClr val="18171F"/>
+                </a:solidFill>
+                <a:latin typeface="Outfit"/>
+              </a:rPr>
+              <a:t>×  Paste a cold question.</a:t>
+            </a:r>
+          </a:p>
+        </p:txBody>
+      </p:sp>
+      <p:sp>
+        <p:nvSpPr>
+          <p:cNvPr id="11" name="TextBox 10"/>
+          <p:cNvSpPr txBox="1"/>
+          <p:nvPr/>
+        </p:nvSpPr>
+        <p:spPr>
+          <a:xfrm>
+            <a:off x="6400800" y="4206240"/>
+            <a:ext cx="5029200" cy="457200"/>
+          </a:xfrm>
+          <a:prstGeom prst="rect">
+            <a:avLst/>
+          </a:prstGeom>
+          <a:noFill/>
+        </p:spPr>
+        <p:txBody>
+          <a:bodyPr wrap="square" lIns="0" rIns="0" tIns="0" bIns="0">
+            <a:spAutoFit/>
+          </a:bodyPr>
+          <a:lstStyle/>
+          <a:p>
+            <a:pPr algn="l"/>
+            <a:r>
+              <a:rPr sz="1500" b="0" i="0">
+                <a:solidFill>
+                  <a:srgbClr val="18171F"/>
+                </a:solidFill>
+                <a:latin typeface="Outfit"/>
+              </a:rPr>
+              <a:t>×  Trust an unverified citation.</a:t>
+            </a:r>
+          </a:p>
+        </p:txBody>
+      </p:sp>
+      <p:sp>
+        <p:nvSpPr>
+          <p:cNvPr id="12" name="TextBox 11"/>
+          <p:cNvSpPr txBox="1"/>
+          <p:nvPr/>
+        </p:nvSpPr>
+        <p:spPr>
+          <a:xfrm>
+            <a:off x="6400800" y="4709160"/>
+            <a:ext cx="5029200" cy="457200"/>
+          </a:xfrm>
+          <a:prstGeom prst="rect">
+            <a:avLst/>
+          </a:prstGeom>
+          <a:noFill/>
+        </p:spPr>
+        <p:txBody>
+          <a:bodyPr wrap="square" lIns="0" rIns="0" tIns="0" bIns="0">
+            <a:spAutoFit/>
+          </a:bodyPr>
+          <a:lstStyle/>
+          <a:p>
+            <a:pPr algn="l"/>
+            <a:r>
+              <a:rPr sz="1500" b="0" i="0">
+                <a:solidFill>
+                  <a:srgbClr val="18171F"/>
+                </a:solidFill>
+                <a:latin typeface="Outfit"/>
+              </a:rPr>
+              <a:t>×  Let it invent data or numbers.</a:t>
+            </a:r>
+          </a:p>
+        </p:txBody>
+      </p:sp>
+      <p:sp>
+        <p:nvSpPr>
+          <p:cNvPr id="13" name="TextBox 12"/>
+          <p:cNvSpPr txBox="1"/>
+          <p:nvPr/>
+        </p:nvSpPr>
+        <p:spPr>
+          <a:xfrm>
+            <a:off x="6400800" y="5212080"/>
+            <a:ext cx="5029200" cy="457200"/>
+          </a:xfrm>
+          <a:prstGeom prst="rect">
+            <a:avLst/>
+          </a:prstGeom>
+          <a:noFill/>
+        </p:spPr>
+        <p:txBody>
+          <a:bodyPr wrap="square" lIns="0" rIns="0" tIns="0" bIns="0">
+            <a:spAutoFit/>
+          </a:bodyPr>
+          <a:lstStyle/>
+          <a:p>
+            <a:pPr algn="l"/>
+            <a:r>
+              <a:rPr sz="1500" b="0" i="0">
+                <a:solidFill>
+                  <a:srgbClr val="18171F"/>
+                </a:solidFill>
+                <a:latin typeface="Outfit"/>
+              </a:rPr>
+              <a:t>×  Ship without checking it.</a:t>
+            </a:r>
+          </a:p>
+        </p:txBody>
+      </p:sp>
+      <p:sp>
+        <p:nvSpPr>
+          <p:cNvPr id="14" name="Rectangle 13"/>
           <p:cNvSpPr/>
           <p:nvPr/>
         </p:nvSpPr>
         <p:spPr>
           <a:xfrm>
-            <a:off x="0" y="0"/>
-            <a:ext cx="12191695" cy="6858000"/>
+            <a:off x="6035040" y="3200400"/>
+            <a:ext cx="12700" cy="2926080"/>
           </a:xfrm>
           <a:prstGeom prst="rect">
             <a:avLst/>
           </a:prstGeom>
           <a:solidFill>
-            <a:srgbClr val="E5E6E0"/>
+            <a:srgbClr val="C7BFB4"/>
           </a:solidFill>
           <a:ln>
             <a:noFill/>
           </a:ln>
-          <a:effectLst/>
         </p:spPr>
         <p:style>
           <a:lnRef idx="1">
@@ -5107,191 +5314,6 @@
           </a:p>
         </p:txBody>
       </p:sp>
-      <p:sp>
-        <p:nvSpPr>
-          <p:cNvPr id="3" name="TextBox 2"/>
-          <p:cNvSpPr txBox="1"/>
-          <p:nvPr/>
-        </p:nvSpPr>
-        <p:spPr>
-          <a:xfrm>
-            <a:off x="822960" y="658368"/>
-            <a:ext cx="9144000" cy="640080"/>
-          </a:xfrm>
-          <a:prstGeom prst="rect">
-            <a:avLst/>
-          </a:prstGeom>
-          <a:noFill/>
-        </p:spPr>
-        <p:txBody>
-          <a:bodyPr wrap="square">
-            <a:spAutoFit/>
-          </a:bodyPr>
-          <a:lstStyle/>
-          <a:p>
-            <a:pPr algn="l">
-              <a:lnSpc>
-                <a:spcPct val="110000"/>
-              </a:lnSpc>
-            </a:pPr>
-            <a:r>
-              <a:rPr sz="3200" b="1">
-                <a:solidFill>
-                  <a:srgbClr val="9E3E58"/>
-                </a:solidFill>
-                <a:latin typeface="Caveat"/>
-              </a:rPr>
-              <a:t>same page</a:t>
-            </a:r>
-          </a:p>
-        </p:txBody>
-      </p:sp>
-      <p:sp>
-        <p:nvSpPr>
-          <p:cNvPr id="4" name="TextBox 3"/>
-          <p:cNvSpPr txBox="1"/>
-          <p:nvPr/>
-        </p:nvSpPr>
-        <p:spPr>
-          <a:xfrm>
-            <a:off x="822960" y="1234440"/>
-            <a:ext cx="10607040" cy="1280160"/>
-          </a:xfrm>
-          <a:prstGeom prst="rect">
-            <a:avLst/>
-          </a:prstGeom>
-          <a:noFill/>
-        </p:spPr>
-        <p:txBody>
-          <a:bodyPr wrap="square">
-            <a:spAutoFit/>
-          </a:bodyPr>
-          <a:lstStyle/>
-          <a:p>
-            <a:pPr algn="l">
-              <a:lnSpc>
-                <a:spcPct val="103000"/>
-              </a:lnSpc>
-            </a:pPr>
-            <a:r>
-              <a:rPr sz="3600" b="1" spc="-150">
-                <a:solidFill>
-                  <a:srgbClr val="18171F"/>
-                </a:solidFill>
-                <a:latin typeface="Space Grotesk"/>
-              </a:rPr>
-              <a:t>Why it makes things up, and the fix</a:t>
-            </a:r>
-          </a:p>
-        </p:txBody>
-      </p:sp>
-      <p:sp>
-        <p:nvSpPr>
-          <p:cNvPr id="5" name="TextBox 4"/>
-          <p:cNvSpPr txBox="1"/>
-          <p:nvPr/>
-        </p:nvSpPr>
-        <p:spPr>
-          <a:xfrm>
-            <a:off x="822960" y="2651760"/>
-            <a:ext cx="10607040" cy="3840480"/>
-          </a:xfrm>
-          <a:prstGeom prst="rect">
-            <a:avLst/>
-          </a:prstGeom>
-          <a:noFill/>
-        </p:spPr>
-        <p:txBody>
-          <a:bodyPr wrap="square">
-            <a:spAutoFit/>
-          </a:bodyPr>
-          <a:lstStyle/>
-          <a:p>
-            <a:pPr>
-              <a:lnSpc>
-                <a:spcPct val="112000"/>
-              </a:lnSpc>
-              <a:spcAft>
-                <a:spcPts val="1600"/>
-              </a:spcAft>
-            </a:pPr>
-            <a:r>
-              <a:rPr sz="2500" b="1" spc="-50">
-                <a:solidFill>
-                  <a:srgbClr val="B30022"/>
-                </a:solidFill>
-                <a:latin typeface="Space Grotesk"/>
-              </a:rPr>
-              <a:t>It predicts.</a:t>
-            </a:r>
-            <a:r>
-              <a:rPr sz="2500">
-                <a:solidFill>
-                  <a:srgbClr val="18171F"/>
-                </a:solidFill>
-                <a:latin typeface="Outfit"/>
-              </a:rPr>
-              <a:t>  A model writes likely text, so it will invent a citation that looks right.</a:t>
-            </a:r>
-          </a:p>
-          <a:p>
-            <a:pPr>
-              <a:lnSpc>
-                <a:spcPct val="112000"/>
-              </a:lnSpc>
-              <a:spcAft>
-                <a:spcPts val="1600"/>
-              </a:spcAft>
-            </a:pPr>
-            <a:r>
-              <a:rPr sz="2500" b="1" spc="-50">
-                <a:solidFill>
-                  <a:srgbClr val="B30022"/>
-                </a:solidFill>
-                <a:latin typeface="Space Grotesk"/>
-              </a:rPr>
-              <a:t>Grounding.</a:t>
-            </a:r>
-            <a:r>
-              <a:rPr sz="2500">
-                <a:solidFill>
-                  <a:srgbClr val="18171F"/>
-                </a:solidFill>
-                <a:latin typeface="Outfit"/>
-              </a:rPr>
-              <a:t>  Give it real sources and tell it to use only those.</a:t>
-            </a:r>
-          </a:p>
-          <a:p>
-            <a:pPr>
-              <a:lnSpc>
-                <a:spcPct val="112000"/>
-              </a:lnSpc>
-              <a:spcAft>
-                <a:spcPts val="1600"/>
-              </a:spcAft>
-            </a:pPr>
-            <a:r>
-              <a:rPr sz="2500" b="1" spc="-50">
-                <a:solidFill>
-                  <a:srgbClr val="B30022"/>
-                </a:solidFill>
-                <a:latin typeface="Space Grotesk"/>
-              </a:rPr>
-              <a:t>Here.</a:t>
-            </a:r>
-            <a:r>
-              <a:rPr sz="2500">
-                <a:solidFill>
-                  <a:srgbClr val="18171F"/>
-                </a:solidFill>
-                <a:latin typeface="Outfit"/>
-              </a:rPr>
-              <a:t>  That is what the literature folder in your workspace is for.</a:t>
-            </a:r>
-          </a:p>
-        </p:txBody>
-      </p:sp>
     </p:spTree>
   </p:cSld>
   <p:clrMapOvr>
@@ -5303,6 +5325,14 @@
 <file path=ppt/slides/slide8.xml><?xml version="1.0" encoding="utf-8"?>
 <p:sld xmlns:a="http://schemas.openxmlformats.org/drawingml/2006/main" xmlns:p="http://schemas.openxmlformats.org/presentationml/2006/main" xmlns:r="http://schemas.openxmlformats.org/officeDocument/2006/relationships">
   <p:cSld>
+    <p:bg>
+      <p:bgPr>
+        <a:solidFill>
+          <a:srgbClr val="18171F"/>
+        </a:solidFill>
+        <a:effectLst/>
+      </p:bgPr>
+    </p:bg>
     <p:spTree>
       <p:nvGrpSpPr>
         <p:cNvPr id="1" name=""/>
@@ -5317,20 +5347,19 @@
           <p:nvPr/>
         </p:nvSpPr>
         <p:spPr>
-          <a:xfrm>
-            <a:off x="0" y="0"/>
-            <a:ext cx="12191695" cy="6858000"/>
-          </a:xfrm>
-          <a:prstGeom prst="rect">
-            <a:avLst/>
-          </a:prstGeom>
-          <a:solidFill>
-            <a:srgbClr val="E5E6E0"/>
-          </a:solidFill>
-          <a:ln>
-            <a:noFill/>
+          <a:xfrm rot="21480000">
+            <a:off x="822960" y="914400"/>
+            <a:ext cx="2194560" cy="384048"/>
+          </a:xfrm>
+          <a:prstGeom prst="rect">
+            <a:avLst/>
+          </a:prstGeom>
+          <a:noFill/>
+          <a:ln w="19050">
+            <a:solidFill>
+              <a:srgbClr val="9E3E58"/>
+            </a:solidFill>
           </a:ln>
-          <a:effectLst/>
         </p:spPr>
         <p:style>
           <a:lnRef idx="1">
@@ -5347,10 +5376,19 @@
           </a:fontRef>
         </p:style>
         <p:txBody>
-          <a:bodyPr rtlCol="0" anchor="ctr"/>
+          <a:bodyPr rtlCol="0" anchor="ctr" lIns="109728" rIns="109728" tIns="36576" bIns="36576"/>
           <a:lstStyle/>
           <a:p>
             <a:pPr algn="ctr"/>
+            <a:r>
+              <a:rPr sz="1000" b="1" spc="200">
+                <a:solidFill>
+                  <a:srgbClr val="9E3E58"/>
+                </a:solidFill>
+                <a:latin typeface="Space Grotesk"/>
+              </a:rPr>
+              <a:t>TOKENS &amp; COST</a:t>
+            </a:r>
           </a:p>
         </p:txBody>
       </p:sp>
@@ -5362,8 +5400,8 @@
         </p:nvSpPr>
         <p:spPr>
           <a:xfrm>
-            <a:off x="822960" y="658368"/>
-            <a:ext cx="9144000" cy="640080"/>
+            <a:off x="822960" y="1554480"/>
+            <a:ext cx="6400800" cy="822960"/>
           </a:xfrm>
           <a:prstGeom prst="rect">
             <a:avLst/>
@@ -5371,24 +5409,20 @@
           <a:noFill/>
         </p:spPr>
         <p:txBody>
-          <a:bodyPr wrap="square">
+          <a:bodyPr wrap="square" lIns="0" rIns="0" tIns="0" bIns="0">
             <a:spAutoFit/>
           </a:bodyPr>
           <a:lstStyle/>
           <a:p>
-            <a:pPr algn="l">
-              <a:lnSpc>
-                <a:spcPct val="110000"/>
-              </a:lnSpc>
-            </a:pPr>
-            <a:r>
-              <a:rPr sz="3200" b="1">
+            <a:pPr algn="l"/>
+            <a:r>
+              <a:rPr sz="3800" b="1" i="0">
                 <a:solidFill>
                   <a:srgbClr val="9E3E58"/>
                 </a:solidFill>
                 <a:latin typeface="Caveat"/>
               </a:rPr>
-              <a:t>good habits</a:t>
+              <a:t>Say it once.</a:t>
             </a:r>
           </a:p>
         </p:txBody>
@@ -5401,8 +5435,8 @@
         </p:nvSpPr>
         <p:spPr>
           <a:xfrm>
-            <a:off x="822960" y="1234440"/>
-            <a:ext cx="10607040" cy="1280160"/>
+            <a:off x="822960" y="2286000"/>
+            <a:ext cx="10058400" cy="2743200"/>
           </a:xfrm>
           <a:prstGeom prst="rect">
             <a:avLst/>
@@ -5410,24 +5444,25 @@
           <a:noFill/>
         </p:spPr>
         <p:txBody>
-          <a:bodyPr wrap="square">
+          <a:bodyPr wrap="square" lIns="0" rIns="0" tIns="0" bIns="0">
             <a:spAutoFit/>
           </a:bodyPr>
           <a:lstStyle/>
           <a:p>
-            <a:pPr algn="l">
-              <a:lnSpc>
-                <a:spcPct val="103000"/>
-              </a:lnSpc>
-            </a:pPr>
-            <a:r>
-              <a:rPr sz="4200" b="1" spc="-150">
-                <a:solidFill>
-                  <a:srgbClr val="18171F"/>
+            <a:pPr algn="l"/>
+            <a:r>
+              <a:rPr sz="8800" b="1" i="0" spc="-200">
+                <a:solidFill>
+                  <a:srgbClr val="E5E6E0"/>
                 </a:solidFill>
                 <a:latin typeface="Space Grotesk"/>
               </a:rPr>
-              <a:t>Set it up to win</a:t>
+              <a:t>CONTEXT SAVES</a:t>
+            </a:r>
+          </a:p>
+          <a:p>
+            <a:r>
+              <a:t>MONEY.</a:t>
             </a:r>
           </a:p>
         </p:txBody>
@@ -5440,8 +5475,8 @@
         </p:nvSpPr>
         <p:spPr>
           <a:xfrm>
-            <a:off x="822960" y="2651760"/>
-            <a:ext cx="10607040" cy="3840480"/>
+            <a:off x="822960" y="5394960"/>
+            <a:ext cx="8686800" cy="1280160"/>
           </a:xfrm>
           <a:prstGeom prst="rect">
             <a:avLst/>
@@ -5449,92 +5484,20 @@
           <a:noFill/>
         </p:spPr>
         <p:txBody>
-          <a:bodyPr wrap="square">
+          <a:bodyPr wrap="square" lIns="0" rIns="0" tIns="0" bIns="0">
             <a:spAutoFit/>
           </a:bodyPr>
           <a:lstStyle/>
           <a:p>
-            <a:pPr>
-              <a:lnSpc>
-                <a:spcPct val="112000"/>
-              </a:lnSpc>
-              <a:spcAft>
-                <a:spcPts val="1600"/>
-              </a:spcAft>
-            </a:pPr>
-            <a:r>
-              <a:rPr sz="2600" b="1" spc="-50">
-                <a:solidFill>
-                  <a:srgbClr val="B30022"/>
-                </a:solidFill>
-                <a:latin typeface="Space Grotesk"/>
-              </a:rPr>
-              <a:t>Context first.</a:t>
-            </a:r>
-            <a:r>
-              <a:rPr sz="2600">
-                <a:solidFill>
-                  <a:srgbClr val="18171F"/>
+            <a:pPr algn="l"/>
+            <a:r>
+              <a:rPr sz="1600" b="0" i="0">
+                <a:solidFill>
+                  <a:srgbClr val="E5E6E0"/>
                 </a:solidFill>
                 <a:latin typeface="Outfit"/>
               </a:rPr>
-              <a:t>  Tell it who you are before you ask for anything.</a:t>
-            </a:r>
-          </a:p>
-          <a:p>
-            <a:pPr>
-              <a:lnSpc>
-                <a:spcPct val="112000"/>
-              </a:lnSpc>
-              <a:spcAft>
-                <a:spcPts val="1600"/>
-              </a:spcAft>
-            </a:pPr>
-            <a:r>
-              <a:rPr sz="2600" b="1" spc="-50">
-                <a:solidFill>
-                  <a:srgbClr val="B30022"/>
-                </a:solidFill>
-                <a:latin typeface="Space Grotesk"/>
-              </a:rPr>
-              <a:t>Be specific.</a:t>
-            </a:r>
-            <a:r>
-              <a:rPr sz="2600">
-                <a:solidFill>
-                  <a:srgbClr val="18171F"/>
-                </a:solidFill>
-                <a:latin typeface="Outfit"/>
-              </a:rPr>
-              <a:t>  State the goal, the audience, and the length.</a:t>
-            </a:r>
-          </a:p>
-          <a:p>
-            <a:pPr>
-              <a:lnSpc>
-                <a:spcPct val="112000"/>
-              </a:lnSpc>
-              <a:spcAft>
-                <a:spcPts val="1600"/>
-              </a:spcAft>
-            </a:pPr>
-            <a:r>
-              <a:rPr sz="2600" b="1" spc="-50">
-                <a:solidFill>
-                  <a:srgbClr val="B30022"/>
-                </a:solidFill>
-                <a:latin typeface="Space Grotesk"/>
-              </a:rPr>
-              <a:t>Point to the rubric.</a:t>
-            </a:r>
-            <a:r>
-              <a:rPr sz="2600">
-                <a:solidFill>
-                  <a:srgbClr val="18171F"/>
-                </a:solidFill>
-                <a:latin typeface="Outfit"/>
-              </a:rPr>
-              <a:t>  Give it the review criteria to hit.</a:t>
+              <a:t>You pay per token, the pieces of text the AI reads and writes. Good context means you say things once instead of every time, which is less work for the model and less money for you.</a:t>
             </a:r>
           </a:p>
         </p:txBody>
@@ -5550,6 +5513,14 @@
 <file path=ppt/slides/slide9.xml><?xml version="1.0" encoding="utf-8"?>
 <p:sld xmlns:a="http://schemas.openxmlformats.org/drawingml/2006/main" xmlns:p="http://schemas.openxmlformats.org/presentationml/2006/main" xmlns:r="http://schemas.openxmlformats.org/officeDocument/2006/relationships">
   <p:cSld>
+    <p:bg>
+      <p:bgPr>
+        <a:solidFill>
+          <a:srgbClr val="E5E6E0"/>
+        </a:solidFill>
+        <a:effectLst/>
+      </p:bgPr>
+    </p:bg>
     <p:spTree>
       <p:nvGrpSpPr>
         <p:cNvPr id="1" name=""/>
@@ -5559,25 +5530,112 @@
       <p:grpSpPr/>
       <p:sp>
         <p:nvSpPr>
-          <p:cNvPr id="2" name="Rectangle 1"/>
+          <p:cNvPr id="2" name="TextBox 1"/>
+          <p:cNvSpPr txBox="1"/>
+          <p:nvPr/>
+        </p:nvSpPr>
+        <p:spPr>
+          <a:xfrm>
+            <a:off x="457200" y="1280160"/>
+            <a:ext cx="11277295" cy="914400"/>
+          </a:xfrm>
+          <a:prstGeom prst="rect">
+            <a:avLst/>
+          </a:prstGeom>
+          <a:noFill/>
+        </p:spPr>
+        <p:txBody>
+          <a:bodyPr wrap="square" lIns="0" rIns="0" tIns="0" bIns="0">
+            <a:spAutoFit/>
+          </a:bodyPr>
+          <a:lstStyle/>
+          <a:p>
+            <a:pPr algn="ctr"/>
+            <a:r>
+              <a:rPr sz="4400" b="1" i="0">
+                <a:solidFill>
+                  <a:srgbClr val="9E3E58"/>
+                </a:solidFill>
+                <a:latin typeface="Caveat"/>
+              </a:rPr>
+              <a:t>Your turn.</a:t>
+            </a:r>
+          </a:p>
+        </p:txBody>
+      </p:sp>
+      <p:sp>
+        <p:nvSpPr>
+          <p:cNvPr id="3" name="TextBox 2"/>
+          <p:cNvSpPr txBox="1"/>
+          <p:nvPr/>
+        </p:nvSpPr>
+        <p:spPr>
+          <a:xfrm>
+            <a:off x="457200" y="2377440"/>
+            <a:ext cx="11277295" cy="1828800"/>
+          </a:xfrm>
+          <a:prstGeom prst="rect">
+            <a:avLst/>
+          </a:prstGeom>
+          <a:noFill/>
+        </p:spPr>
+        <p:txBody>
+          <a:bodyPr wrap="none" lIns="0" rIns="0" tIns="0" bIns="0">
+            <a:spAutoFit/>
+          </a:bodyPr>
+          <a:lstStyle/>
+          <a:p>
+            <a:pPr algn="ctr"/>
+            <a:r>
+              <a:rPr sz="10800" b="1" spc="-200">
+                <a:solidFill>
+                  <a:srgbClr val="18171F"/>
+                </a:solidFill>
+                <a:latin typeface="Space Grotesk"/>
+              </a:rPr>
+              <a:t>LET'S BUILD IT.</a:t>
+            </a:r>
+            <a:r>
+              <a:rPr sz="10800" b="1" spc="-200">
+                <a:solidFill>
+                  <a:srgbClr val="B30022"/>
+                </a:solidFill>
+                <a:latin typeface="Space Grotesk"/>
+              </a:rPr>
+              <a:t/>
+            </a:r>
+            <a:r>
+              <a:rPr sz="10800" b="1" spc="-200">
+                <a:solidFill>
+                  <a:srgbClr val="18171F"/>
+                </a:solidFill>
+                <a:latin typeface="Space Grotesk"/>
+              </a:rPr>
+              <a:t/>
+            </a:r>
+          </a:p>
+        </p:txBody>
+      </p:sp>
+      <p:sp>
+        <p:nvSpPr>
+          <p:cNvPr id="4" name="Rectangle 3"/>
           <p:cNvSpPr/>
           <p:nvPr/>
         </p:nvSpPr>
         <p:spPr>
           <a:xfrm>
-            <a:off x="0" y="0"/>
-            <a:ext cx="12191695" cy="6858000"/>
+            <a:off x="4861407" y="4160520"/>
+            <a:ext cx="2468880" cy="76200"/>
           </a:xfrm>
           <a:prstGeom prst="rect">
             <a:avLst/>
           </a:prstGeom>
           <a:solidFill>
-            <a:srgbClr val="E5E6E0"/>
+            <a:srgbClr val="B30022"/>
           </a:solidFill>
           <a:ln>
             <a:noFill/>
           </a:ln>
-          <a:effectLst/>
         </p:spPr>
         <p:style>
           <a:lnRef idx="1">
@@ -5603,14 +5661,14 @@
       </p:sp>
       <p:sp>
         <p:nvSpPr>
-          <p:cNvPr id="3" name="TextBox 2"/>
+          <p:cNvPr id="5" name="TextBox 4"/>
           <p:cNvSpPr txBox="1"/>
           <p:nvPr/>
         </p:nvSpPr>
         <p:spPr>
           <a:xfrm>
-            <a:off x="822960" y="658368"/>
-            <a:ext cx="9144000" cy="640080"/>
+            <a:off x="1371600" y="4937760"/>
+            <a:ext cx="9418320" cy="1097280"/>
           </a:xfrm>
           <a:prstGeom prst="rect">
             <a:avLst/>
@@ -5618,38 +5676,34 @@
           <a:noFill/>
         </p:spPr>
         <p:txBody>
-          <a:bodyPr wrap="square">
+          <a:bodyPr wrap="square" lIns="0" rIns="0" tIns="0" bIns="0">
             <a:spAutoFit/>
           </a:bodyPr>
           <a:lstStyle/>
           <a:p>
-            <a:pPr algn="l">
-              <a:lnSpc>
-                <a:spcPct val="110000"/>
-              </a:lnSpc>
-            </a:pPr>
-            <a:r>
-              <a:rPr sz="3200" b="1">
-                <a:solidFill>
-                  <a:srgbClr val="9E3E58"/>
-                </a:solidFill>
-                <a:latin typeface="Caveat"/>
+            <a:pPr algn="ctr"/>
+            <a:r>
+              <a:rPr sz="1600" b="0" i="0">
+                <a:solidFill>
+                  <a:srgbClr val="3D3B47"/>
+                </a:solidFill>
+                <a:latin typeface="Outfit"/>
               </a:rPr>
-              <a:t>good habits</a:t>
-            </a:r>
-          </a:p>
-        </p:txBody>
-      </p:sp>
-      <p:sp>
-        <p:nvSpPr>
-          <p:cNvPr id="4" name="TextBox 3"/>
+              <a:t>Context in, grounded help out. Now we open the workspace and set up yours.</a:t>
+            </a:r>
+          </a:p>
+        </p:txBody>
+      </p:sp>
+      <p:sp>
+        <p:nvSpPr>
+          <p:cNvPr id="6" name="TextBox 5"/>
           <p:cNvSpPr txBox="1"/>
           <p:nvPr/>
         </p:nvSpPr>
         <p:spPr>
           <a:xfrm>
-            <a:off x="822960" y="1234440"/>
-            <a:ext cx="10607040" cy="1280160"/>
+            <a:off x="457200" y="6217920"/>
+            <a:ext cx="11277295" cy="365760"/>
           </a:xfrm>
           <a:prstGeom prst="rect">
             <a:avLst/>
@@ -5657,131 +5711,20 @@
           <a:noFill/>
         </p:spPr>
         <p:txBody>
-          <a:bodyPr wrap="square">
+          <a:bodyPr wrap="square" lIns="0" rIns="0" tIns="0" bIns="0">
             <a:spAutoFit/>
           </a:bodyPr>
           <a:lstStyle/>
           <a:p>
-            <a:pPr algn="l">
-              <a:lnSpc>
-                <a:spcPct val="103000"/>
-              </a:lnSpc>
-            </a:pPr>
-            <a:r>
-              <a:rPr sz="4200" b="1" spc="-150">
-                <a:solidFill>
-                  <a:srgbClr val="18171F"/>
+            <a:pPr algn="ctr"/>
+            <a:r>
+              <a:rPr sz="1100" b="1" i="0" spc="400">
+                <a:solidFill>
+                  <a:srgbClr val="9E3E58"/>
                 </a:solidFill>
                 <a:latin typeface="Space Grotesk"/>
               </a:rPr>
-              <a:t>Keep it honest</a:t>
-            </a:r>
-          </a:p>
-        </p:txBody>
-      </p:sp>
-      <p:sp>
-        <p:nvSpPr>
-          <p:cNvPr id="5" name="TextBox 4"/>
-          <p:cNvSpPr txBox="1"/>
-          <p:nvPr/>
-        </p:nvSpPr>
-        <p:spPr>
-          <a:xfrm>
-            <a:off x="822960" y="2651760"/>
-            <a:ext cx="10607040" cy="3840480"/>
-          </a:xfrm>
-          <a:prstGeom prst="rect">
-            <a:avLst/>
-          </a:prstGeom>
-          <a:noFill/>
-        </p:spPr>
-        <p:txBody>
-          <a:bodyPr wrap="square">
-            <a:spAutoFit/>
-          </a:bodyPr>
-          <a:lstStyle/>
-          <a:p>
-            <a:pPr>
-              <a:lnSpc>
-                <a:spcPct val="112000"/>
-              </a:lnSpc>
-              <a:spcAft>
-                <a:spcPts val="1600"/>
-              </a:spcAft>
-            </a:pPr>
-            <a:r>
-              <a:rPr sz="2600" b="1" spc="-50">
-                <a:solidFill>
-                  <a:srgbClr val="B30022"/>
-                </a:solidFill>
-                <a:latin typeface="Space Grotesk"/>
-              </a:rPr>
-              <a:t>Ground every claim.</a:t>
-            </a:r>
-            <a:r>
-              <a:rPr sz="2600">
-                <a:solidFill>
-                  <a:srgbClr val="18171F"/>
-                </a:solidFill>
-                <a:latin typeface="Outfit"/>
-              </a:rPr>
-              <a:t>  Tie it to a real source you provided.</a:t>
-            </a:r>
-          </a:p>
-          <a:p>
-            <a:pPr>
-              <a:lnSpc>
-                <a:spcPct val="112000"/>
-              </a:lnSpc>
-              <a:spcAft>
-                <a:spcPts val="1600"/>
-              </a:spcAft>
-            </a:pPr>
-            <a:r>
-              <a:rPr sz="2600" b="1" spc="-50">
-                <a:solidFill>
-                  <a:srgbClr val="B30022"/>
-                </a:solidFill>
-                <a:latin typeface="Space Grotesk"/>
-              </a:rPr>
-              <a:t>Trust nothing unverified.</a:t>
-            </a:r>
-            <a:r>
-              <a:rPr sz="2600">
-                <a:solidFill>
-                  <a:srgbClr val="18171F"/>
-                </a:solidFill>
-                <a:latin typeface="Outfit"/>
-              </a:rPr>
-              <a:t>  Check every citation and statistic yourself.</a:t>
-            </a:r>
-          </a:p>
-          <a:p>
-            <a:pPr>
-              <a:lnSpc>
-                <a:spcPct val="112000"/>
-              </a:lnSpc>
-              <a:spcAft>
-                <a:spcPts val="1600"/>
-              </a:spcAft>
-            </a:pPr>
-            <a:r>
-              <a:rPr sz="2600" b="1" spc="-50">
-                <a:solidFill>
-                  <a:srgbClr val="B30022"/>
-                </a:solidFill>
-                <a:latin typeface="Space Grotesk"/>
-              </a:rPr>
-              <a:t>Let it say I do not know.</a:t>
-            </a:r>
-            <a:r>
-              <a:rPr sz="2600">
-                <a:solidFill>
-                  <a:srgbClr val="18171F"/>
-                </a:solidFill>
-                <a:latin typeface="Outfit"/>
-              </a:rPr>
-              <a:t>  If it cannot support a claim, it should flag it, not fake it.</a:t>
+              <a:t>ashleyscruse.com</a:t>
             </a:r>
           </a:p>
         </p:txBody>

</xml_diff>